<commit_message>
Give the slide numbers room; two-digit numbers were wrapping
The box was 0.30" wide, but textbox() defaults to word_wrap=True and python-pptx adds
0.1" side margins -- leaving roughly 0.10" of usable width. Enough for one digit, so
every number from 10 up broke onto two lines.

Three fixes, because any one alone would have been fragile:
  * widened to 0.35" (the right-hand gutter is 0.43", so this still clears content)
  * zeroed the text-frame margins, which were consuming two thirds of the box
  * set word_wrap = False, so a page number can never wrap whatever its width

Verified by rendering and cropping the corner on slide 16 and on slide 12 -- a
two-digit number beside content that runs out to x=12.85 -- rather than only checking
the geometry, plus a programmatic pass confirming all 16 stamps are present, non-wrapping
and free of overlap.

Assisted-By: Claude Opus 5 (1M context) <noreply@anthropic.com>
</commit_message>
<xml_diff>
--- a/docs/AutoBench.pptx
+++ b/docs/AutoBench.pptx
@@ -3358,7 +3358,7 @@
                 </a:solidFill>
                 <a:latin typeface="Calibri"/>
               </a:rPr>
-              <a:t>Last modified 2026-09-09 14:47 EDT</a:t>
+              <a:t>Last modified 2026-09-09 14:53 EDT</a:t>
             </a:r>
           </a:p>
         </p:txBody>
@@ -3371,8 +3371,8 @@
         </p:nvSpPr>
         <p:spPr>
           <a:xfrm>
-            <a:off x="11841480" y="6455664"/>
-            <a:ext cx="274320" cy="274320"/>
+            <a:off x="11795760" y="6437376"/>
+            <a:ext cx="320040" cy="310896"/>
           </a:xfrm>
           <a:prstGeom prst="rect">
             <a:avLst/>
@@ -3380,7 +3380,7 @@
           <a:noFill/>
         </p:spPr>
         <p:txBody>
-          <a:bodyPr wrap="square" anchor="ctr">
+          <a:bodyPr wrap="none" anchor="ctr" lIns="0" rIns="0" tIns="0" bIns="0">
             <a:spAutoFit/>
           </a:bodyPr>
           <a:lstStyle/>
@@ -4505,8 +4505,8 @@
         </p:nvSpPr>
         <p:spPr>
           <a:xfrm>
-            <a:off x="11841480" y="6455664"/>
-            <a:ext cx="274320" cy="274320"/>
+            <a:off x="11795760" y="6437376"/>
+            <a:ext cx="320040" cy="310896"/>
           </a:xfrm>
           <a:prstGeom prst="rect">
             <a:avLst/>
@@ -4514,7 +4514,7 @@
           <a:noFill/>
         </p:spPr>
         <p:txBody>
-          <a:bodyPr wrap="square" anchor="ctr">
+          <a:bodyPr wrap="none" anchor="ctr" lIns="0" rIns="0" tIns="0" bIns="0">
             <a:spAutoFit/>
           </a:bodyPr>
           <a:lstStyle/>
@@ -4961,8 +4961,8 @@
         </p:nvSpPr>
         <p:spPr>
           <a:xfrm>
-            <a:off x="11841480" y="6455664"/>
-            <a:ext cx="274320" cy="274320"/>
+            <a:off x="11795760" y="6437376"/>
+            <a:ext cx="320040" cy="310896"/>
           </a:xfrm>
           <a:prstGeom prst="rect">
             <a:avLst/>
@@ -4970,7 +4970,7 @@
           <a:noFill/>
         </p:spPr>
         <p:txBody>
-          <a:bodyPr wrap="square" anchor="ctr">
+          <a:bodyPr wrap="none" anchor="ctr" lIns="0" rIns="0" tIns="0" bIns="0">
             <a:spAutoFit/>
           </a:bodyPr>
           <a:lstStyle/>
@@ -6687,8 +6687,8 @@
         </p:nvSpPr>
         <p:spPr>
           <a:xfrm>
-            <a:off x="11841480" y="6455664"/>
-            <a:ext cx="274320" cy="274320"/>
+            <a:off x="11795760" y="6437376"/>
+            <a:ext cx="320040" cy="310896"/>
           </a:xfrm>
           <a:prstGeom prst="rect">
             <a:avLst/>
@@ -6696,7 +6696,7 @@
           <a:noFill/>
         </p:spPr>
         <p:txBody>
-          <a:bodyPr wrap="square" anchor="ctr">
+          <a:bodyPr wrap="none" anchor="ctr" lIns="0" rIns="0" tIns="0" bIns="0">
             <a:spAutoFit/>
           </a:bodyPr>
           <a:lstStyle/>
@@ -8693,8 +8693,8 @@
         </p:nvSpPr>
         <p:spPr>
           <a:xfrm>
-            <a:off x="11841480" y="6455664"/>
-            <a:ext cx="274320" cy="274320"/>
+            <a:off x="11795760" y="6437376"/>
+            <a:ext cx="320040" cy="310896"/>
           </a:xfrm>
           <a:prstGeom prst="rect">
             <a:avLst/>
@@ -8702,7 +8702,7 @@
           <a:noFill/>
         </p:spPr>
         <p:txBody>
-          <a:bodyPr wrap="square" anchor="ctr">
+          <a:bodyPr wrap="none" anchor="ctr" lIns="0" rIns="0" tIns="0" bIns="0">
             <a:spAutoFit/>
           </a:bodyPr>
           <a:lstStyle/>
@@ -11299,8 +11299,8 @@
         </p:nvSpPr>
         <p:spPr>
           <a:xfrm>
-            <a:off x="11841480" y="6455664"/>
-            <a:ext cx="274320" cy="274320"/>
+            <a:off x="11795760" y="6437376"/>
+            <a:ext cx="320040" cy="310896"/>
           </a:xfrm>
           <a:prstGeom prst="rect">
             <a:avLst/>
@@ -11308,7 +11308,7 @@
           <a:noFill/>
         </p:spPr>
         <p:txBody>
-          <a:bodyPr wrap="square" anchor="ctr">
+          <a:bodyPr wrap="none" anchor="ctr" lIns="0" rIns="0" tIns="0" bIns="0">
             <a:spAutoFit/>
           </a:bodyPr>
           <a:lstStyle/>
@@ -12403,8 +12403,8 @@
         </p:nvSpPr>
         <p:spPr>
           <a:xfrm>
-            <a:off x="11841480" y="6455664"/>
-            <a:ext cx="274320" cy="274320"/>
+            <a:off x="11795760" y="6437376"/>
+            <a:ext cx="320040" cy="310896"/>
           </a:xfrm>
           <a:prstGeom prst="rect">
             <a:avLst/>
@@ -12412,7 +12412,7 @@
           <a:noFill/>
         </p:spPr>
         <p:txBody>
-          <a:bodyPr wrap="square" anchor="ctr">
+          <a:bodyPr wrap="none" anchor="ctr" lIns="0" rIns="0" tIns="0" bIns="0">
             <a:spAutoFit/>
           </a:bodyPr>
           <a:lstStyle/>
@@ -13007,8 +13007,8 @@
         </p:nvSpPr>
         <p:spPr>
           <a:xfrm>
-            <a:off x="11841480" y="6455664"/>
-            <a:ext cx="274320" cy="274320"/>
+            <a:off x="11795760" y="6437376"/>
+            <a:ext cx="320040" cy="310896"/>
           </a:xfrm>
           <a:prstGeom prst="rect">
             <a:avLst/>
@@ -13016,7 +13016,7 @@
           <a:noFill/>
         </p:spPr>
         <p:txBody>
-          <a:bodyPr wrap="square" anchor="ctr">
+          <a:bodyPr wrap="none" anchor="ctr" lIns="0" rIns="0" tIns="0" bIns="0">
             <a:spAutoFit/>
           </a:bodyPr>
           <a:lstStyle/>
@@ -14494,8 +14494,8 @@
         </p:nvSpPr>
         <p:spPr>
           <a:xfrm>
-            <a:off x="11841480" y="6455664"/>
-            <a:ext cx="274320" cy="274320"/>
+            <a:off x="11795760" y="6437376"/>
+            <a:ext cx="320040" cy="310896"/>
           </a:xfrm>
           <a:prstGeom prst="rect">
             <a:avLst/>
@@ -14503,7 +14503,7 @@
           <a:noFill/>
         </p:spPr>
         <p:txBody>
-          <a:bodyPr wrap="square" anchor="ctr">
+          <a:bodyPr wrap="none" anchor="ctr" lIns="0" rIns="0" tIns="0" bIns="0">
             <a:spAutoFit/>
           </a:bodyPr>
           <a:lstStyle/>
@@ -15414,8 +15414,8 @@
         </p:nvSpPr>
         <p:spPr>
           <a:xfrm>
-            <a:off x="11841480" y="6455664"/>
-            <a:ext cx="274320" cy="274320"/>
+            <a:off x="11795760" y="6437376"/>
+            <a:ext cx="320040" cy="310896"/>
           </a:xfrm>
           <a:prstGeom prst="rect">
             <a:avLst/>
@@ -15423,7 +15423,7 @@
           <a:noFill/>
         </p:spPr>
         <p:txBody>
-          <a:bodyPr wrap="square" anchor="ctr">
+          <a:bodyPr wrap="none" anchor="ctr" lIns="0" rIns="0" tIns="0" bIns="0">
             <a:spAutoFit/>
           </a:bodyPr>
           <a:lstStyle/>
@@ -17144,8 +17144,8 @@
         </p:nvSpPr>
         <p:spPr>
           <a:xfrm>
-            <a:off x="11841480" y="6455664"/>
-            <a:ext cx="274320" cy="274320"/>
+            <a:off x="11795760" y="6437376"/>
+            <a:ext cx="320040" cy="310896"/>
           </a:xfrm>
           <a:prstGeom prst="rect">
             <a:avLst/>
@@ -17153,7 +17153,7 @@
           <a:noFill/>
         </p:spPr>
         <p:txBody>
-          <a:bodyPr wrap="square" anchor="ctr">
+          <a:bodyPr wrap="none" anchor="ctr" lIns="0" rIns="0" tIns="0" bIns="0">
             <a:spAutoFit/>
           </a:bodyPr>
           <a:lstStyle/>
@@ -19549,8 +19549,8 @@
         </p:nvSpPr>
         <p:spPr>
           <a:xfrm>
-            <a:off x="11841480" y="6455664"/>
-            <a:ext cx="274320" cy="274320"/>
+            <a:off x="11795760" y="6437376"/>
+            <a:ext cx="320040" cy="310896"/>
           </a:xfrm>
           <a:prstGeom prst="rect">
             <a:avLst/>
@@ -19558,7 +19558,7 @@
           <a:noFill/>
         </p:spPr>
         <p:txBody>
-          <a:bodyPr wrap="square" anchor="ctr">
+          <a:bodyPr wrap="none" anchor="ctr" lIns="0" rIns="0" tIns="0" bIns="0">
             <a:spAutoFit/>
           </a:bodyPr>
           <a:lstStyle/>
@@ -22293,8 +22293,8 @@
         </p:nvSpPr>
         <p:spPr>
           <a:xfrm>
-            <a:off x="11841480" y="6455664"/>
-            <a:ext cx="274320" cy="274320"/>
+            <a:off x="11795760" y="6437376"/>
+            <a:ext cx="320040" cy="310896"/>
           </a:xfrm>
           <a:prstGeom prst="rect">
             <a:avLst/>
@@ -22302,7 +22302,7 @@
           <a:noFill/>
         </p:spPr>
         <p:txBody>
-          <a:bodyPr wrap="square" anchor="ctr">
+          <a:bodyPr wrap="none" anchor="ctr" lIns="0" rIns="0" tIns="0" bIns="0">
             <a:spAutoFit/>
           </a:bodyPr>
           <a:lstStyle/>
@@ -22833,8 +22833,8 @@
         </p:nvSpPr>
         <p:spPr>
           <a:xfrm>
-            <a:off x="11841480" y="6455664"/>
-            <a:ext cx="274320" cy="274320"/>
+            <a:off x="11795760" y="6437376"/>
+            <a:ext cx="320040" cy="310896"/>
           </a:xfrm>
           <a:prstGeom prst="rect">
             <a:avLst/>
@@ -22842,7 +22842,7 @@
           <a:noFill/>
         </p:spPr>
         <p:txBody>
-          <a:bodyPr wrap="square" anchor="ctr">
+          <a:bodyPr wrap="none" anchor="ctr" lIns="0" rIns="0" tIns="0" bIns="0">
             <a:spAutoFit/>
           </a:bodyPr>
           <a:lstStyle/>
@@ -23873,8 +23873,8 @@
         </p:nvSpPr>
         <p:spPr>
           <a:xfrm>
-            <a:off x="11841480" y="6455664"/>
-            <a:ext cx="274320" cy="274320"/>
+            <a:off x="11795760" y="6437376"/>
+            <a:ext cx="320040" cy="310896"/>
           </a:xfrm>
           <a:prstGeom prst="rect">
             <a:avLst/>
@@ -23882,7 +23882,7 @@
           <a:noFill/>
         </p:spPr>
         <p:txBody>
-          <a:bodyPr wrap="square" anchor="ctr">
+          <a:bodyPr wrap="none" anchor="ctr" lIns="0" rIns="0" tIns="0" bIns="0">
             <a:spAutoFit/>
           </a:bodyPr>
           <a:lstStyle/>
@@ -25205,8 +25205,8 @@
         </p:nvSpPr>
         <p:spPr>
           <a:xfrm>
-            <a:off x="11841480" y="6455664"/>
-            <a:ext cx="274320" cy="274320"/>
+            <a:off x="11795760" y="6437376"/>
+            <a:ext cx="320040" cy="310896"/>
           </a:xfrm>
           <a:prstGeom prst="rect">
             <a:avLst/>
@@ -25214,7 +25214,7 @@
           <a:noFill/>
         </p:spPr>
         <p:txBody>
-          <a:bodyPr wrap="square" anchor="ctr">
+          <a:bodyPr wrap="none" anchor="ctr" lIns="0" rIns="0" tIns="0" bIns="0">
             <a:spAutoFit/>
           </a:bodyPr>
           <a:lstStyle/>

</xml_diff>

<commit_message>
Retitle slide 3: "Implementation Architecture: Kubernetes-Based Benchmark Workloads"
"3. Architecture" said nothing about what the slide shows. The new title
names the subject — how the benchmark workloads are laid out on Kubernetes —
and, because the deck's PDF bookmarks are generated from each slide's title
text, it now reads usefully in the outline too.

Verified: the 68-char title still renders on one line inside the navy band
at 26pt and clears both the diagram and the page number.

Assisted-By: Claude Opus 5 <noreply@anthropic.com>
</commit_message>
<xml_diff>
--- a/docs/AutoBench.pptx
+++ b/docs/AutoBench.pptx
@@ -3358,7 +3358,7 @@
                 </a:solidFill>
                 <a:latin typeface="Calibri"/>
               </a:rPr>
-              <a:t>Last modified 2026-09-11 21:53 EDT</a:t>
+              <a:t>Last modified 2026-09-11 22:06 EDT</a:t>
             </a:r>
           </a:p>
         </p:txBody>
@@ -17350,7 +17350,7 @@
 
 <file path=ppt/slides/slide5.xml><?xml version="1.0" encoding="utf-8"?>
 <p:sld xmlns:a="http://schemas.openxmlformats.org/drawingml/2006/main" xmlns:p="http://schemas.openxmlformats.org/presentationml/2006/main" xmlns:r="http://schemas.openxmlformats.org/officeDocument/2006/relationships">
-  <p:cSld name="3. Architecture">
+  <p:cSld name="3. Implementation Architecture: Kubernetes-Based Benchmark Workloads">
     <p:spTree>
       <p:nvGrpSpPr>
         <p:cNvPr id="1" name=""/>
@@ -17406,7 +17406,7 @@
                 </a:solidFill>
                 <a:latin typeface="Calibri"/>
               </a:rPr>
-              <a:t>3.  Architecture</a:t>
+              <a:t>3.  Implementation Architecture: Kubernetes-Based Benchmark Workloads</a:t>
             </a:r>
           </a:p>
           <a:p>

</xml_diff>

<commit_message>
Capitalise Internet in the deck's gateway bar
It is the named global network there, not a generic adjective; intranet stays
lowercase because it is not. The lowercase `internet` elsewhere in the repo is
the literal LLM_PROFILE value and is left alone.

Assisted-By: Claude Opus 5 <noreply@anthropic.com>
Signed-off-by: Rong Chang <rong@us.ibm.com>
</commit_message>
<xml_diff>
--- a/docs/AutoBench.pptx
+++ b/docs/AutoBench.pptx
@@ -3369,7 +3369,7 @@
                 </a:solidFill>
                 <a:latin typeface="Calibri"/>
               </a:rPr>
-              <a:t>Last modified 2026-09-29 20:59 EDT</a:t>
+              <a:t>Last modified 2026-09-29 21:03 EDT</a:t>
             </a:r>
           </a:p>
         </p:txBody>
@@ -32267,7 +32267,7 @@
                 </a:solidFill>
                 <a:latin typeface="Calibri"/>
               </a:rPr>
-              <a:t>LLM gateway (per instance)   ·   ete-litellm   ·   external (vpc) for internet OCP / internal (vpc-int) for intranet KinD and OCP</a:t>
+              <a:t>LLM gateway (per instance)   ·   ete-litellm   ·   external (vpc) for Internet OCP / internal (vpc-int) for intranet KinD and OCP</a:t>
             </a:r>
           </a:p>
         </p:txBody>

</xml_diff>

<commit_message>
Render the v1.35 deck and guide PDFs
docs/AutoBench.pptx/.pdf and both guide PDFs, regenerated from the
v1.35 sources. Two slide fixes found while inspecting the render:
slide 3 no longer places MLflow apart from a "workload cluster", and
slide 9.2's title says what v1.35 measured (almost all of the cost is
the judge) instead of "why it has no single number".

Assisted-By: Claude Opus 5.5 <noreply@anthropic.com>
Signed-off-by: Rong Chang <rong@us.ibm.com>
</commit_message>
<xml_diff>
--- a/docs/AutoBench.pptx
+++ b/docs/AutoBench.pptx
@@ -3330,7 +3330,7 @@
                 </a:solidFill>
                 <a:latin typeface="Calibri"/>
               </a:rPr>
-              <a:t>across multiple cluster-specific Rossoctl instances.</a:t>
+              <a:t>on a Rossoctl cluster, alongside the workloads it benchmarks.</a:t>
             </a:r>
           </a:p>
         </p:txBody>
@@ -3369,7 +3369,7 @@
                 </a:solidFill>
                 <a:latin typeface="Calibri"/>
               </a:rPr>
-              <a:t>Last modified 2026-09-29 21:18 EDT</a:t>
+              <a:t>Last modified 2026-10-05 20:12 EDT</a:t>
             </a:r>
           </a:p>
         </p:txBody>
@@ -4482,7 +4482,7 @@
                           </a:solidFill>
                           <a:latin typeface="Calibri"/>
                         </a:rPr>
-                        <a:t>connect_mcp — tools/list  →  MCP pod   (per task, not per pod; ~27–38 ms)</a:t>
+                        <a:t>connect_mcp — tools/list  →  MCP pod   (per task, not per pod; ~40–50 ms)</a:t>
                       </a:r>
                     </a:p>
                   </a:txBody>
@@ -4553,7 +4553,7 @@
                           </a:solidFill>
                           <a:latin typeface="Calibri"/>
                         </a:rPr>
-                        <a:t>create_agent   (6.7 ms warm, up to 6.5 s on a cold pod)</a:t>
+                        <a:t>create_agent   (~12–15 ms warm, up to 5.2 s on a cold pod)</a:t>
                       </a:r>
                     </a:p>
                   </a:txBody>
@@ -4624,7 +4624,7 @@
                           </a:solidFill>
                           <a:latin typeface="Calibri"/>
                         </a:rPr>
-                        <a:t>initial_observation — local, no I/O, ~50 µs</a:t>
+                        <a:t>initial_observation — local, no I/O, ~70 µs</a:t>
                       </a:r>
                     </a:p>
                   </a:txBody>
@@ -5008,7 +5008,7 @@
                 </a:solidFill>
                 <a:latin typeface="Calibri"/>
               </a:rPr>
-              <a:t>Everything the agent does happens inside that single streaming request. Its POST / span brackets it, so Agent.Call − POST / is the Service's own cost: 16.9 ms of a 10.4 s gsm8k task, 13.2 ms of a 70.3 s tau2 one.</a:t>
+              <a:t>Everything the agent does happens inside that single streaming request. Its POST / span brackets it, so Agent.Call − POST / is the Service's own cost: a median 16.3 ms of a 2.5 s gsm8k task, 15.9 ms of a 40 s tau2 one.</a:t>
             </a:r>
           </a:p>
         </p:txBody>
@@ -5712,7 +5712,7 @@
                 </a:solidFill>
                 <a:latin typeface="Calibri"/>
               </a:rPr>
-              <a:t>Same task id, same model, same platform, two different legs: tau2 task 2 took 13 chat / 13 tool in one and 9 / 9 in the other; appworld 3d9a636_3 took 20 / 10 and 26 / 13. Of tasks appearing in more than one leg, 8 of 10 tau2 and 3 of 3 appworld differ — the 10 that agree are all gsm8k, where 1 chat / 1 tool leaves nothing to vary.</a:t>
+              <a:t>Same task id, same model, same platform, two different legs: tau2 task 7 took 12 chat / 12 tool in one and 10 / 10 in the other; appworld 3d9a636_3 took 24 / 12 and 20 / 10. Of tasks appearing in more than one leg, 14 of 20 tau2 and 10 of 10 appworld differ, while all 20 gsm8k tasks agree — 1 chat / 1 tool leaves nothing to vary.</a:t>
             </a:r>
           </a:p>
         </p:txBody>
@@ -5779,7 +5779,7 @@
                 </a:solidFill>
                 <a:latin typeface="Calibri"/>
               </a:rPr>
-              <a:t>No terminal tool name exists anywhere in the Service. The agent reads the tool declarations at connect_mcp, and gsm8k's whole first model call is 320 input tokens — system prompt, task text and every schema. It lands: submit 173/173 on gsm8k, finish 34/35 on appworld (the miss timed out), while tau2 has NO terminal tool — 60/60 end on message.</a:t>
+              <a:t>No terminal tool name exists anywhere in the Service. The agent reads the tool declarations at connect_mcp, and gsm8k's whole first model call is 320 input tokens — system prompt, task text and every schema. It lands: submit 172/172 on gsm8k, finish 41/49 on appworld (the rest stopped on the agent's own defect), while tau2 has NO terminal tool — 60/60 end on message.</a:t>
             </a:r>
           </a:p>
         </p:txBody>
@@ -6443,7 +6443,7 @@
                           </a:solidFill>
                           <a:latin typeface="Calibri"/>
                         </a:rPr>
-                        <a:t>35 of 50 (15 timed out)</a:t>
+                        <a:t>49 of 50 (1 timed out)</a:t>
                       </a:r>
                     </a:p>
                   </a:txBody>
@@ -6585,7 +6585,7 @@
                           </a:solidFill>
                           <a:latin typeface="Calibri"/>
                         </a:rPr>
-                        <a:t>0.97</a:t>
+                        <a:t>0.98</a:t>
                       </a:r>
                     </a:p>
                   </a:txBody>
@@ -6608,7 +6608,7 @@
                           </a:solidFill>
                           <a:latin typeface="Calibri"/>
                         </a:rPr>
-                        <a:t>0.83</a:t>
+                        <a:t>0.90</a:t>
                       </a:r>
                     </a:p>
                   </a:txBody>
@@ -6679,7 +6679,7 @@
                           </a:solidFill>
                           <a:latin typeface="Calibri"/>
                         </a:rPr>
-                        <a:t>341</a:t>
+                        <a:t>343</a:t>
                       </a:r>
                     </a:p>
                   </a:txBody>
@@ -6702,7 +6702,7 @@
                           </a:solidFill>
                           <a:latin typeface="Calibri"/>
                         </a:rPr>
-                        <a:t>90,902</a:t>
+                        <a:t>87,935</a:t>
                       </a:r>
                     </a:p>
                   </a:txBody>
@@ -6725,7 +6725,7 @@
                           </a:solidFill>
                           <a:latin typeface="Calibri"/>
                         </a:rPr>
-                        <a:t>269,953</a:t>
+                        <a:t>291,509</a:t>
                       </a:r>
                     </a:p>
                   </a:txBody>
@@ -6773,7 +6773,7 @@
                           </a:solidFill>
                           <a:latin typeface="Calibri"/>
                         </a:rPr>
-                        <a:t>180</a:t>
+                        <a:t>170</a:t>
                       </a:r>
                     </a:p>
                   </a:txBody>
@@ -6796,7 +6796,7 @@
                           </a:solidFill>
                           <a:latin typeface="Calibri"/>
                         </a:rPr>
-                        <a:t>2,061</a:t>
+                        <a:t>2,071</a:t>
                       </a:r>
                     </a:p>
                   </a:txBody>
@@ -6819,7 +6819,7 @@
                           </a:solidFill>
                           <a:latin typeface="Calibri"/>
                         </a:rPr>
-                        <a:t>25,140</a:t>
+                        <a:t>26,950</a:t>
                       </a:r>
                     </a:p>
                   </a:txBody>
@@ -6867,7 +6867,7 @@
                           </a:solidFill>
                           <a:latin typeface="Calibri"/>
                         </a:rPr>
-                        <a:t>$0.00055</a:t>
+                        <a:t>$0.00053</a:t>
                       </a:r>
                     </a:p>
                   </a:txBody>
@@ -6890,7 +6890,7 @@
                           </a:solidFill>
                           <a:latin typeface="Calibri"/>
                         </a:rPr>
-                        <a:t>$0.154</a:t>
+                        <a:t>$0.149</a:t>
                       </a:r>
                     </a:p>
                   </a:txBody>
@@ -6913,7 +6913,7 @@
                           </a:solidFill>
                           <a:latin typeface="Calibri"/>
                         </a:rPr>
-                        <a:t>$0.589</a:t>
+                        <a:t>$0.634</a:t>
                       </a:r>
                     </a:p>
                   </a:txBody>
@@ -6984,7 +6984,7 @@
                           </a:solidFill>
                           <a:latin typeface="Calibri"/>
                         </a:rPr>
-                        <a:t>11.4</a:t>
+                        <a:t>11.1</a:t>
                       </a:r>
                     </a:p>
                   </a:txBody>
@@ -7007,7 +7007,7 @@
                           </a:solidFill>
                           <a:latin typeface="Calibri"/>
                         </a:rPr>
-                        <a:t>29.2</a:t>
+                        <a:t>30.2</a:t>
                       </a:r>
                     </a:p>
                   </a:txBody>
@@ -7078,7 +7078,7 @@
                           </a:solidFill>
                           <a:latin typeface="Calibri"/>
                         </a:rPr>
-                        <a:t>11.4</a:t>
+                        <a:t>11.1</a:t>
                       </a:r>
                     </a:p>
                   </a:txBody>
@@ -7101,7 +7101,7 @@
                           </a:solidFill>
                           <a:latin typeface="Calibri"/>
                         </a:rPr>
-                        <a:t>14.6</a:t>
+                        <a:t>14.9</a:t>
                       </a:r>
                     </a:p>
                   </a:txBody>
@@ -7149,7 +7149,7 @@
                           </a:solidFill>
                           <a:latin typeface="Calibri"/>
                         </a:rPr>
-                        <a:t>4.9 s</a:t>
+                        <a:t>2.5 s</a:t>
                       </a:r>
                     </a:p>
                   </a:txBody>
@@ -7172,7 +7172,7 @@
                           </a:solidFill>
                           <a:latin typeface="Calibri"/>
                         </a:rPr>
-                        <a:t>84 s</a:t>
+                        <a:t>48 s</a:t>
                       </a:r>
                     </a:p>
                   </a:txBody>
@@ -7195,7 +7195,7 @@
                           </a:solidFill>
                           <a:latin typeface="Calibri"/>
                         </a:rPr>
-                        <a:t>264 s</a:t>
+                        <a:t>222 s</a:t>
                       </a:r>
                     </a:p>
                   </a:txBody>
@@ -7243,7 +7243,7 @@
                           </a:solidFill>
                           <a:latin typeface="Calibri"/>
                         </a:rPr>
-                        <a:t>39 s</a:t>
+                        <a:t>15 s</a:t>
                       </a:r>
                     </a:p>
                   </a:txBody>
@@ -7266,7 +7266,7 @@
                           </a:solidFill>
                           <a:latin typeface="Calibri"/>
                         </a:rPr>
-                        <a:t>136 s</a:t>
+                        <a:t>75 s</a:t>
                       </a:r>
                     </a:p>
                   </a:txBody>
@@ -7289,7 +7289,7 @@
                           </a:solidFill>
                           <a:latin typeface="Calibri"/>
                         </a:rPr>
-                        <a:t>592 s</a:t>
+                        <a:t>591 s</a:t>
                       </a:r>
                     </a:p>
                   </a:txBody>
@@ -7448,7 +7448,7 @@
                 </a:solidFill>
                 <a:latin typeface="Calibri"/>
               </a:rPr>
-              <a:t>Read the MODEL row before any dollar figure: the three rungs do not run the same model, and each default is dearer than the one below it — so no cost here transfers to another model. The scale gap is the headline: a tau2 task costs ~267× the input tokens of a gsm8k task, an appworld task ~792× — and in MONEY 279× and 1,069×, because that model change compounds with the token growth (7.6, 7.8). A 50-task gsm8k run is a minute and 2 cents; a 20-task appworld run is 30-45 minutes, millions of tokens and dollars. Budget by benchmark, not by task count.</a:t>
+              <a:t>Read the MODEL row before any dollar figure: the three rungs do not run the same model, and each default is dearer than the one below it — so no cost here transfers to another model. The scale gap is the headline: a tau2 task costs ~256× the input tokens of a gsm8k task, an appworld task ~850× — and in MONEY 282× and 1,195×, because that model change compounds with the token growth (7.6, 7.8). A 50-task gsm8k run is half a minute and 2 cents; a 20-task appworld run is ~25 minutes, millions of tokens and dollars. Budget by benchmark, not by task count.</a:t>
             </a:r>
           </a:p>
         </p:txBody>
@@ -7779,7 +7779,7 @@
                 </a:solidFill>
                 <a:latin typeface="Calibri"/>
               </a:rPr>
-              <a:t>• Cheap enough to run often: a 50-task leg is 25 K tokens — 0.4% of the whole 12-run matrix's bill, and less than a SINGLE appworld task (see 7.5).</a:t>
+              <a:t>• Cheap enough to run often: a 50-task leg is ~24 K tokens — 0.1% of the whole 12-run matrix's bill, and less than a SINGLE appworld task (see 7.5).</a:t>
             </a:r>
           </a:p>
         </p:txBody>
@@ -8044,7 +8044,7 @@
                 </a:solidFill>
                 <a:latin typeface="Calibri"/>
               </a:rPr>
-              <a:t>• 27% of a task's wall time sits INSIDE tool calls — that is the simulator generating, server-side, and its tokens appear in no report of ours.</a:t>
+              <a:t>• 22% of a task's wall time sits INSIDE tool calls — that is the simulator generating, server-side, and its tokens appear in no report of ours.</a:t>
             </a:r>
           </a:p>
         </p:txBody>
@@ -8229,7 +8229,7 @@
                 </a:solidFill>
                 <a:latin typeface="Calibri"/>
               </a:rPr>
-              <a:t>• ~29 LLM calls, ~15 tool calls, ~270k input, ~4.5 min per task.</a:t>
+              <a:t>• ~30 LLM calls, ~15 tool calls, ~290k input, ~3.7 min per task.</a:t>
             </a:r>
           </a:p>
           <a:p>
@@ -8277,7 +8277,7 @@
                 </a:solidFill>
                 <a:latin typeface="Calibri"/>
               </a:rPr>
-              <a:t>• 34 of 35 measured tasks call finish: it believes it is done and the assertions disagree. No verification pass.</a:t>
+              <a:t>• 41 of 49 measured tasks call finish: it believes it is done and the assertions disagree. No verification pass.</a:t>
             </a:r>
           </a:p>
           <a:p>
@@ -8309,7 +8309,7 @@
                 </a:solidFill>
                 <a:latin typeface="Calibri"/>
               </a:rPr>
-              <a:t>• Two model calls per tool call — tool shortlisting, which only bites with an API surface this large. The first carries 68% of the input tokens.</a:t>
+              <a:t>• Two model calls per tool call — tool shortlisting, which only bites with an API surface this large. The first carries 67% of the input tokens.</a:t>
             </a:r>
           </a:p>
         </p:txBody>
@@ -8789,7 +8789,7 @@
                           </a:solidFill>
                           <a:latin typeface="Calibri"/>
                         </a:rPr>
-                        <a:t>~29 calls, each re-sending the
+                        <a:t>~30 calls, each re-sending the
 whole conversation</a:t>
                       </a:r>
                     </a:p>
@@ -9156,7 +9156,7 @@
                         </a:rPr>
                         <a:t>a genuine model/config
 comparison — it discriminates,
-and 0.83 leaves headroom both ways</a:t>
+and 0.90 leaves headroom both ways</a:t>
                       </a:r>
                     </a:p>
                   </a:txBody>
@@ -9277,8 +9277,9 @@
                           </a:solidFill>
                           <a:latin typeface="Calibri"/>
                         </a:rPr>
-                        <a:t>15 of 50 tasks time out, and a
-killed task leaves NO report row</a:t>
+                        <a:t>long tasks can hit the 600 s
+timeout, and a killed task
+leaves NO report row</a:t>
                       </a:r>
                     </a:p>
                   </a:txBody>
@@ -9343,7 +9344,7 @@
                 </a:solidFill>
                 <a:latin typeface="Calibri"/>
               </a:rPr>
-              <a:t>gsm8k is a SMOKE TEST WITH A SCORE — reading its 0.97 as a model measurement is the most common misreading of these numbers.  tau2 is the only rung that discriminates, and it fails informatively: a wrong answer, a policy violation and a dropped thread are different failures.  appworld earns its place precisely BECAUSE it fails — it is the only leg that has ever exposed a timeout, a context limit or a cache effect before a user did.</a:t>
+              <a:t>gsm8k is a SMOKE TEST WITH A SCORE — reading its 0.98 as a model measurement is the most common misreading of these numbers.  tau2 is the only rung that discriminates, and it fails informatively: a wrong answer, a policy violation and a dropped thread are different failures.  appworld earns its place precisely BECAUSE it fails — it is the only leg that has ever exposed a timeout, a context limit or a cache effect before a user did.</a:t>
             </a:r>
           </a:p>
         </p:txBody>
@@ -9598,7 +9599,7 @@
                 </a:solidFill>
                 <a:latin typeface="Calibri"/>
               </a:rPr>
-              <a:t>Agents up to exgentic 0.3.5.dev131 issued a max_tokens=1 capability probe counted as a chat span, so THEIR llm=2 on gsm8k means ONE real call. From dev145 the probe is an unbilled GET /v1/models that emits no span — verified absent across all 1,895 chat spans of these two matrices. Current runs count real calls 1:1, with no offset to subtract.</a:t>
+              <a:t>Agents up to exgentic 0.3.5.dev131 issued a max_tokens=1 capability probe counted as a chat span, so THEIR llm=2 on gsm8k means ONE real call. The current agent sends no such probe — verified absent across all 2,338 chat spans of these two matrices. Current runs count real calls 1:1, with no offset to subtract.</a:t>
             </a:r>
           </a:p>
         </p:txBody>
@@ -9732,7 +9733,7 @@
                 </a:solidFill>
                 <a:latin typeface="Calibri"/>
               </a:rPr>
-              <a:t>Measured OUT CV &gt; IN CV in 15 of the 22 legs that ran more than one task. On a one-call model gsm8k's prompt is near-constant while answer length swings (IN 0.06-0.09 vs OUT 0.52-0.86); gpt-4.1 needs tool round-trips and varies on the input side too (IN 0.39-0.44). Only long-horizon appworld is input-led, in all four of its legs. Read the CV, not the mechanism.</a:t>
+              <a:t>Measured OUT CV &gt; IN CV in 16 of the 22 legs that ran more than one task. On a one-call model gsm8k's prompt is near-constant while answer length swings (IN 0.06-0.09 vs OUT 0.55-0.99); gpt-4.1 needs tool round-trips and varies on the input side too (IN 0.38-0.44). Only long-horizon appworld is input-led, in all four of its legs. Read the CV, not the mechanism.</a:t>
             </a:r>
           </a:p>
         </p:txBody>
@@ -9799,7 +9800,7 @@
                 </a:solidFill>
                 <a:latin typeface="Calibri"/>
               </a:rPr>
-              <a:t>A run takes the first max_tasks tasks, so the same task_id is the same task across runs and clusters, and a smaller run is a prefix of a larger one. That is what makes cross-platform comparison like-for-like — six legs matched to the byte.</a:t>
+              <a:t>A run takes the first max_tasks tasks, so the same task_id is the same task across runs and clusters, and a smaller run is a prefix of a larger one. That is what makes cross-platform comparison like-for-like — seven legs matched to the byte.</a:t>
             </a:r>
           </a:p>
         </p:txBody>
@@ -10221,7 +10222,7 @@
                           </a:solidFill>
                           <a:latin typeface="Calibri"/>
                         </a:rPr>
-                        <a:t>$1.70 / 10</a:t>
+                        <a:t>$1.60 / 10</a:t>
                       </a:r>
                     </a:p>
                   </a:txBody>
@@ -10292,7 +10293,7 @@
                           </a:solidFill>
                           <a:latin typeface="Calibri"/>
                         </a:rPr>
-                        <a:t>$1.90–2.80 / 5</a:t>
+                        <a:t>$3.10–3.40 / 5</a:t>
                       </a:r>
                     </a:p>
                   </a:txBody>
@@ -10417,7 +10418,7 @@
                           </a:solidFill>
                           <a:latin typeface="Calibri"/>
                         </a:rPr>
-                        <a:t>leg (v1.28)</a:t>
+                        <a:t>leg (v1.35)</a:t>
                       </a:r>
                     </a:p>
                   </a:txBody>
@@ -10557,7 +10558,7 @@
                           </a:solidFill>
                           <a:latin typeface="Calibri"/>
                         </a:rPr>
-                        <a:t>470</a:t>
+                        <a:t>406</a:t>
                       </a:r>
                     </a:p>
                   </a:txBody>
@@ -10580,7 +10581,7 @@
                           </a:solidFill>
                           <a:latin typeface="Calibri"/>
                         </a:rPr>
-                        <a:t>$0.0004</a:t>
+                        <a:t>$0.0003</a:t>
                       </a:r>
                     </a:p>
                   </a:txBody>
@@ -10603,7 +10604,7 @@
                           </a:solidFill>
                           <a:latin typeface="Calibri"/>
                         </a:rPr>
-                        <a:t>790</a:t>
+                        <a:t>406</a:t>
                       </a:r>
                     </a:p>
                   </a:txBody>
@@ -10626,7 +10627,7 @@
                           </a:solidFill>
                           <a:latin typeface="Calibri"/>
                         </a:rPr>
-                        <a:t>$0.0010</a:t>
+                        <a:t>$0.0003</a:t>
                       </a:r>
                     </a:p>
                   </a:txBody>
@@ -10791,6 +10792,52 @@
                           </a:solidFill>
                           <a:latin typeface="Calibri"/>
                         </a:rPr>
+                        <a:t>24 K</a:t>
+                      </a:r>
+                    </a:p>
+                  </a:txBody>
+                  <a:tcPr marL="63500" marR="63500" marT="12700" marB="12700" anchor="ctr">
+                    <a:solidFill>
+                      <a:srgbClr val="FFFFFF"/>
+                    </a:solidFill>
+                  </a:tcPr>
+                </a:tc>
+                <a:tc>
+                  <a:txBody>
+                    <a:bodyPr/>
+                    <a:lstStyle/>
+                    <a:p>
+                      <a:pPr algn="ctr"/>
+                      <a:r>
+                        <a:rPr sz="1050" b="0" i="0">
+                          <a:solidFill>
+                            <a:srgbClr val="1F2A37"/>
+                          </a:solidFill>
+                          <a:latin typeface="Calibri"/>
+                        </a:rPr>
+                        <a:t>$0.020</a:t>
+                      </a:r>
+                    </a:p>
+                  </a:txBody>
+                  <a:tcPr marL="63500" marR="63500" marT="12700" marB="12700" anchor="ctr">
+                    <a:solidFill>
+                      <a:srgbClr val="FFFFFF"/>
+                    </a:solidFill>
+                  </a:tcPr>
+                </a:tc>
+                <a:tc>
+                  <a:txBody>
+                    <a:bodyPr/>
+                    <a:lstStyle/>
+                    <a:p>
+                      <a:pPr algn="ctr"/>
+                      <a:r>
+                        <a:rPr sz="1050" b="0" i="0">
+                          <a:solidFill>
+                            <a:srgbClr val="1F2A37"/>
+                          </a:solidFill>
+                          <a:latin typeface="Calibri"/>
+                        </a:rPr>
                         <a:t>25 K</a:t>
                       </a:r>
                     </a:p>
@@ -10814,53 +10861,7 @@
                           </a:solidFill>
                           <a:latin typeface="Calibri"/>
                         </a:rPr>
-                        <a:t>$0.023</a:t>
-                      </a:r>
-                    </a:p>
-                  </a:txBody>
-                  <a:tcPr marL="63500" marR="63500" marT="12700" marB="12700" anchor="ctr">
-                    <a:solidFill>
-                      <a:srgbClr val="FFFFFF"/>
-                    </a:solidFill>
-                  </a:tcPr>
-                </a:tc>
-                <a:tc>
-                  <a:txBody>
-                    <a:bodyPr/>
-                    <a:lstStyle/>
-                    <a:p>
-                      <a:pPr algn="ctr"/>
-                      <a:r>
-                        <a:rPr sz="1050" b="0" i="0">
-                          <a:solidFill>
-                            <a:srgbClr val="1F2A37"/>
-                          </a:solidFill>
-                          <a:latin typeface="Calibri"/>
-                        </a:rPr>
-                        <a:t>24 K</a:t>
-                      </a:r>
-                    </a:p>
-                  </a:txBody>
-                  <a:tcPr marL="63500" marR="63500" marT="12700" marB="12700" anchor="ctr">
-                    <a:solidFill>
-                      <a:srgbClr val="FFFFFF"/>
-                    </a:solidFill>
-                  </a:tcPr>
-                </a:tc>
-                <a:tc>
-                  <a:txBody>
-                    <a:bodyPr/>
-                    <a:lstStyle/>
-                    <a:p>
-                      <a:pPr algn="ctr"/>
-                      <a:r>
-                        <a:rPr sz="1050" b="0" i="0">
-                          <a:solidFill>
-                            <a:srgbClr val="1F2A37"/>
-                          </a:solidFill>
-                          <a:latin typeface="Calibri"/>
-                        </a:rPr>
-                        <a:t>$0.021</a:t>
+                        <a:t>$0.022</a:t>
                       </a:r>
                     </a:p>
                   </a:txBody>
@@ -10908,7 +10909,7 @@
                           </a:solidFill>
                           <a:latin typeface="Calibri"/>
                         </a:rPr>
-                        <a:t>1.01 M</a:t>
+                        <a:t>0.96 M</a:t>
                       </a:r>
                     </a:p>
                   </a:txBody>
@@ -10931,7 +10932,7 @@
                           </a:solidFill>
                           <a:latin typeface="Calibri"/>
                         </a:rPr>
-                        <a:t>$1.66</a:t>
+                        <a:t>$1.59</a:t>
                       </a:r>
                     </a:p>
                   </a:txBody>
@@ -10954,7 +10955,7 @@
                           </a:solidFill>
                           <a:latin typeface="Calibri"/>
                         </a:rPr>
-                        <a:t>1.04 M</a:t>
+                        <a:t>0.94 M</a:t>
                       </a:r>
                     </a:p>
                   </a:txBody>
@@ -10977,7 +10978,7 @@
                           </a:solidFill>
                           <a:latin typeface="Calibri"/>
                         </a:rPr>
-                        <a:t>$1.73</a:t>
+                        <a:t>$1.56</a:t>
                       </a:r>
                     </a:p>
                   </a:txBody>
@@ -11048,7 +11049,7 @@
                           </a:solidFill>
                           <a:latin typeface="Calibri"/>
                         </a:rPr>
-                        <a:t>$2.90</a:t>
+                        <a:t>$2.88</a:t>
                       </a:r>
                     </a:p>
                   </a:txBody>
@@ -11071,7 +11072,7 @@
                           </a:solidFill>
                           <a:latin typeface="Calibri"/>
                         </a:rPr>
-                        <a:t>1.78 M</a:t>
+                        <a:t>1.77 M</a:t>
                       </a:r>
                     </a:p>
                   </a:txBody>
@@ -11094,7 +11095,7 @@
                           </a:solidFill>
                           <a:latin typeface="Calibri"/>
                         </a:rPr>
-                        <a:t>$2.94</a:t>
+                        <a:t>$2.93</a:t>
                       </a:r>
                     </a:p>
                   </a:txBody>
@@ -11142,7 +11143,7 @@
                           </a:solidFill>
                           <a:latin typeface="Calibri"/>
                         </a:rPr>
-                        <a:t>1.49 M</a:t>
+                        <a:t>1.55 M</a:t>
                       </a:r>
                     </a:p>
                   </a:txBody>
@@ -11165,7 +11166,7 @@
                           </a:solidFill>
                           <a:latin typeface="Calibri"/>
                         </a:rPr>
-                        <a:t>$2.79</a:t>
+                        <a:t>$3.10</a:t>
                       </a:r>
                     </a:p>
                   </a:txBody>
@@ -11188,7 +11189,7 @@
                           </a:solidFill>
                           <a:latin typeface="Calibri"/>
                         </a:rPr>
-                        <a:t>0.93 M</a:t>
+                        <a:t>1.71 M</a:t>
                       </a:r>
                     </a:p>
                   </a:txBody>
@@ -11211,7 +11212,7 @@
                           </a:solidFill>
                           <a:latin typeface="Calibri"/>
                         </a:rPr>
-                        <a:t>$1.90</a:t>
+                        <a:t>$3.39</a:t>
                       </a:r>
                     </a:p>
                   </a:txBody>
@@ -11259,7 +11260,7 @@
                           </a:solidFill>
                           <a:latin typeface="Calibri"/>
                         </a:rPr>
-                        <a:t>5.71 M</a:t>
+                        <a:t>6.47 M</a:t>
                       </a:r>
                     </a:p>
                   </a:txBody>
@@ -11282,7 +11283,7 @@
                           </a:solidFill>
                           <a:latin typeface="Calibri"/>
                         </a:rPr>
-                        <a:t>$11.52</a:t>
+                        <a:t>$12.63</a:t>
                       </a:r>
                     </a:p>
                   </a:txBody>
@@ -11305,7 +11306,7 @@
                           </a:solidFill>
                           <a:latin typeface="Calibri"/>
                         </a:rPr>
-                        <a:t>2.20 M</a:t>
+                        <a:t>5.87 M</a:t>
                       </a:r>
                     </a:p>
                   </a:txBody>
@@ -11328,7 +11329,7 @@
                           </a:solidFill>
                           <a:latin typeface="Calibri"/>
                         </a:rPr>
-                        <a:t>$4.40</a:t>
+                        <a:t>$11.94</a:t>
                       </a:r>
                     </a:p>
                   </a:txBody>
@@ -11376,7 +11377,7 @@
                           </a:solidFill>
                           <a:latin typeface="Calibri"/>
                         </a:rPr>
-                        <a:t>10.0 M</a:t>
+                        <a:t>10.8 M</a:t>
                       </a:r>
                     </a:p>
                   </a:txBody>
@@ -11399,7 +11400,7 @@
                           </a:solidFill>
                           <a:latin typeface="Calibri"/>
                         </a:rPr>
-                        <a:t>$18.91</a:t>
+                        <a:t>$20.25</a:t>
                       </a:r>
                     </a:p>
                   </a:txBody>
@@ -11422,7 +11423,7 @@
                           </a:solidFill>
                           <a:latin typeface="Calibri"/>
                         </a:rPr>
-                        <a:t>6.0 M</a:t>
+                        <a:t>10.3 M</a:t>
                       </a:r>
                     </a:p>
                   </a:txBody>
@@ -11445,7 +11446,7 @@
                           </a:solidFill>
                           <a:latin typeface="Calibri"/>
                         </a:rPr>
-                        <a:t>$11.02</a:t>
+                        <a:t>$19.87</a:t>
                       </a:r>
                     </a:p>
                   </a:txBody>
@@ -11522,7 +11523,7 @@
                 </a:solidFill>
                 <a:latin typeface="Calibri"/>
               </a:rPr>
-              <a:t>The eight gsm8k legs together are 0.2% of the matrix's bill on OpenShift (0.4% on KinD). appworld's two legs are 76% of it (57%); tau2's two are 24% (42%). A 50-task gsm8k leg costs 2 cents — less than a twenty-fifth of a SINGLE appworld task.</a:t>
+              <a:t>The eight gsm8k legs together are 0.2% of the matrix's bill on both platforms. appworld's two legs are 78% of it on OpenShift (77% on KinD); tau2's two are 22% (23%). A 50-task gsm8k leg costs 2 cents — about a thirtieth of a SINGLE appworld task.</a:t>
             </a:r>
           </a:p>
         </p:txBody>
@@ -11577,7 +11578,7 @@
                 </a:solidFill>
                 <a:latin typeface="Calibri"/>
               </a:rPr>
-              <a:t>Two legs of the same size are not the same bill</a:t>
+              <a:t>The same work, close to the same bill — not by law</a:t>
             </a:r>
           </a:p>
           <a:p>
@@ -11589,7 +11590,7 @@
                 </a:solidFill>
                 <a:latin typeface="Calibri"/>
               </a:rPr>
-              <a:t>#12 cost 2.6× more on OpenShift than on KinD for the same 20 requested tasks: appworld turn counts are nondeterministic, and the slower cluster's tasks ran longer before the 600 s timeout. So the two $18.91 / $11.02 totals are NOT a platform comparison — OpenShift completed 18 appworld tasks against KinD's 10. Size appworld on YOUR cluster.</a:t>
+              <a:t>The two totals land within 2% ($20.25 / $19.87), #12 within 6%: the same request bodies through one gateway. But appworld turn counts are nondeterministic (21 tasks completed on OpenShift, 20 on KinD), and a cluster whose tasks run longer before the 600 s timeout bills more for the same work. Size appworld on YOUR cluster.</a:t>
             </a:r>
           </a:p>
         </p:txBody>
@@ -11644,7 +11645,7 @@
                 </a:solidFill>
                 <a:latin typeface="Calibri"/>
               </a:rPr>
-              <a:t>And the totals UNDERSTATE it three ways:  a task killed by the per-task timeout burns tokens but leaves no report row, so appworld's 15 timed-out tasks are missing from the numbers above.  tau2's user simulator runs in the MCP pod, which is not instrumented — its inference is billed by the gateway and counted nowhere here.  And a leg that replays the gateway's completion cache re-reports stored usage for calls that were never made upstream.  7.7 puts a dollar figure on the fourth: the IBAC judge, which the agent's spans never see.</a:t>
+              <a:t>And the totals UNDERSTATE it three ways:  a task killed by the per-task timeout burns tokens but leaves no report row, so appworld's one timed-out task is missing from the numbers above.  tau2's user simulator runs in the MCP pod, which is not instrumented — its inference is billed by the gateway and counted nowhere here.  And a leg that replays the gateway's completion cache re-reports stored usage for calls that were never made upstream.  7.7 puts a dollar figure on the fourth: the IBAC judge, which the agent's spans never see.</a:t>
             </a:r>
           </a:p>
         </p:txBody>
@@ -12113,7 +12114,7 @@
                           </a:solidFill>
                           <a:latin typeface="Calibri"/>
                         </a:rPr>
-                        <a:t>1.10</a:t>
+                        <a:t>1.11</a:t>
                       </a:r>
                     </a:p>
                   </a:txBody>
@@ -12136,7 +12137,7 @@
                           </a:solidFill>
                           <a:latin typeface="Calibri"/>
                         </a:rPr>
-                        <a:t>11.38</a:t>
+                        <a:t>11.10</a:t>
                       </a:r>
                     </a:p>
                   </a:txBody>
@@ -12159,7 +12160,7 @@
                           </a:solidFill>
                           <a:latin typeface="Calibri"/>
                         </a:rPr>
-                        <a:t>29.20</a:t>
+                        <a:t>30.22</a:t>
                       </a:r>
                     </a:p>
                   </a:txBody>
@@ -12207,7 +12208,7 @@
                           </a:solidFill>
                           <a:latin typeface="Calibri"/>
                         </a:rPr>
-                        <a:t>341</a:t>
+                        <a:t>343</a:t>
                       </a:r>
                     </a:p>
                   </a:txBody>
@@ -12230,7 +12231,7 @@
                           </a:solidFill>
                           <a:latin typeface="Calibri"/>
                         </a:rPr>
-                        <a:t>90,902</a:t>
+                        <a:t>87,935</a:t>
                       </a:r>
                     </a:p>
                   </a:txBody>
@@ -12253,7 +12254,7 @@
                           </a:solidFill>
                           <a:latin typeface="Calibri"/>
                         </a:rPr>
-                        <a:t>269,953</a:t>
+                        <a:t>291,509</a:t>
                       </a:r>
                     </a:p>
                   </a:txBody>
@@ -12301,7 +12302,7 @@
                           </a:solidFill>
                           <a:latin typeface="Calibri"/>
                         </a:rPr>
-                        <a:t>180</a:t>
+                        <a:t>170</a:t>
                       </a:r>
                     </a:p>
                   </a:txBody>
@@ -12324,7 +12325,7 @@
                           </a:solidFill>
                           <a:latin typeface="Calibri"/>
                         </a:rPr>
-                        <a:t>2,061</a:t>
+                        <a:t>2,071</a:t>
                       </a:r>
                     </a:p>
                   </a:txBody>
@@ -12347,7 +12348,7 @@
                           </a:solidFill>
                           <a:latin typeface="Calibri"/>
                         </a:rPr>
-                        <a:t>25,140</a:t>
+                        <a:t>26,950</a:t>
                       </a:r>
                     </a:p>
                   </a:txBody>
@@ -12395,7 +12396,7 @@
                           </a:solidFill>
                           <a:latin typeface="Calibri"/>
                         </a:rPr>
-                        <a:t>520</a:t>
+                        <a:t>513</a:t>
                       </a:r>
                     </a:p>
                   </a:txBody>
@@ -12418,7 +12419,7 @@
                           </a:solidFill>
                           <a:latin typeface="Calibri"/>
                         </a:rPr>
-                        <a:t>92,963</a:t>
+                        <a:t>90,006</a:t>
                       </a:r>
                     </a:p>
                   </a:txBody>
@@ -12441,7 +12442,7 @@
                           </a:solidFill>
                           <a:latin typeface="Calibri"/>
                         </a:rPr>
-                        <a:t>295,093</a:t>
+                        <a:t>318,459</a:t>
                       </a:r>
                     </a:p>
                   </a:txBody>
@@ -12512,7 +12513,7 @@
                           </a:solidFill>
                           <a:latin typeface="Calibri"/>
                         </a:rPr>
-                        <a:t>178×</a:t>
+                        <a:t>175×</a:t>
                       </a:r>
                     </a:p>
                   </a:txBody>
@@ -12535,7 +12536,7 @@
                           </a:solidFill>
                           <a:latin typeface="Calibri"/>
                         </a:rPr>
-                        <a:t>564×</a:t>
+                        <a:t>621×</a:t>
                       </a:r>
                     </a:p>
                   </a:txBody>
@@ -12583,7 +12584,7 @@
                           </a:solidFill>
                           <a:latin typeface="Calibri"/>
                         </a:rPr>
-                        <a:t>$0.00055</a:t>
+                        <a:t>$0.00053</a:t>
                       </a:r>
                     </a:p>
                   </a:txBody>
@@ -12606,7 +12607,7 @@
                           </a:solidFill>
                           <a:latin typeface="Calibri"/>
                         </a:rPr>
-                        <a:t>$0.154</a:t>
+                        <a:t>$0.149</a:t>
                       </a:r>
                     </a:p>
                   </a:txBody>
@@ -12629,7 +12630,7 @@
                           </a:solidFill>
                           <a:latin typeface="Calibri"/>
                         </a:rPr>
-                        <a:t>$0.589</a:t>
+                        <a:t>$0.634</a:t>
                       </a:r>
                     </a:p>
                   </a:txBody>
@@ -12700,7 +12701,7 @@
                           </a:solidFill>
                           <a:latin typeface="Calibri"/>
                         </a:rPr>
-                        <a:t>279×</a:t>
+                        <a:t>282×</a:t>
                       </a:r>
                     </a:p>
                   </a:txBody>
@@ -12723,7 +12724,7 @@
                           </a:solidFill>
                           <a:latin typeface="Calibri"/>
                         </a:rPr>
-                        <a:t>1,069×</a:t>
+                        <a:t>1,195×</a:t>
                       </a:r>
                     </a:p>
                   </a:txBody>
@@ -12771,7 +12772,7 @@
                           </a:solidFill>
                           <a:latin typeface="Calibri"/>
                         </a:rPr>
-                        <a:t>$0.06</a:t>
+                        <a:t>$0.05</a:t>
                       </a:r>
                     </a:p>
                   </a:txBody>
@@ -12794,7 +12795,7 @@
                           </a:solidFill>
                           <a:latin typeface="Calibri"/>
                         </a:rPr>
-                        <a:t>$15.38</a:t>
+                        <a:t>$14.94</a:t>
                       </a:r>
                     </a:p>
                   </a:txBody>
@@ -12817,7 +12818,7 @@
                           </a:solidFill>
                           <a:latin typeface="Calibri"/>
                         </a:rPr>
-                        <a:t>$58.88</a:t>
+                        <a:t>$63.39</a:t>
                       </a:r>
                     </a:p>
                   </a:txBody>
@@ -12865,7 +12866,7 @@
                           </a:solidFill>
                           <a:latin typeface="Calibri"/>
                         </a:rPr>
-                        <a:t>66%</a:t>
+                        <a:t>67%</a:t>
                       </a:r>
                     </a:p>
                   </a:txBody>
@@ -12959,7 +12960,7 @@
                           </a:solidFill>
                           <a:latin typeface="Calibri"/>
                         </a:rPr>
-                        <a:t>31%</a:t>
+                        <a:t>32%</a:t>
                       </a:r>
                     </a:p>
                   </a:txBody>
@@ -12982,7 +12983,7 @@
                           </a:solidFill>
                           <a:latin typeface="Calibri"/>
                         </a:rPr>
-                        <a:t>90%</a:t>
+                        <a:t>89%</a:t>
                       </a:r>
                     </a:p>
                   </a:txBody>
@@ -13053,7 +13054,7 @@
                           </a:solidFill>
                           <a:latin typeface="Calibri"/>
                         </a:rPr>
-                        <a:t>4.9 s</a:t>
+                        <a:t>2.5 s</a:t>
                       </a:r>
                     </a:p>
                   </a:txBody>
@@ -13076,7 +13077,7 @@
                           </a:solidFill>
                           <a:latin typeface="Calibri"/>
                         </a:rPr>
-                        <a:t>84 s</a:t>
+                        <a:t>48 s</a:t>
                       </a:r>
                     </a:p>
                   </a:txBody>
@@ -13099,7 +13100,7 @@
                           </a:solidFill>
                           <a:latin typeface="Calibri"/>
                         </a:rPr>
-                        <a:t>264 s</a:t>
+                        <a:t>222 s</a:t>
                       </a:r>
                     </a:p>
                   </a:txBody>
@@ -13147,7 +13148,7 @@
                           </a:solidFill>
                           <a:latin typeface="Calibri"/>
                         </a:rPr>
-                        <a:t>90%</a:t>
+                        <a:t>82%</a:t>
                       </a:r>
                     </a:p>
                   </a:txBody>
@@ -13170,7 +13171,7 @@
                           </a:solidFill>
                           <a:latin typeface="Calibri"/>
                         </a:rPr>
-                        <a:t>58%</a:t>
+                        <a:t>60%</a:t>
                       </a:r>
                     </a:p>
                   </a:txBody>
@@ -13193,7 +13194,7 @@
                           </a:solidFill>
                           <a:latin typeface="Calibri"/>
                         </a:rPr>
-                        <a:t>96%</a:t>
+                        <a:t>95%</a:t>
                       </a:r>
                     </a:p>
                   </a:txBody>
@@ -13241,7 +13242,7 @@
                           </a:solidFill>
                           <a:latin typeface="Calibri"/>
                         </a:rPr>
-                        <a:t>0.97</a:t>
+                        <a:t>0.98</a:t>
                       </a:r>
                     </a:p>
                   </a:txBody>
@@ -13264,7 +13265,7 @@
                           </a:solidFill>
                           <a:latin typeface="Calibri"/>
                         </a:rPr>
-                        <a:t>0.83</a:t>
+                        <a:t>0.90</a:t>
                       </a:r>
                     </a:p>
                   </a:txBody>
@@ -13433,7 +13434,7 @@
                           </a:solidFill>
                           <a:latin typeface="Calibri"/>
                         </a:rPr>
-                        <a:t>0.80 / 1.00</a:t>
+                        <a:t>0.80 / 0.80</a:t>
                       </a:r>
                     </a:p>
                   </a:txBody>
@@ -13575,7 +13576,7 @@
                           </a:solidFill>
                           <a:latin typeface="Calibri"/>
                         </a:rPr>
-                        <a:t>775 – 837</a:t>
+                        <a:t>782 – 835</a:t>
                       </a:r>
                     </a:p>
                   </a:txBody>
@@ -13646,7 +13647,7 @@
                           </a:solidFill>
                           <a:latin typeface="Calibri"/>
                         </a:rPr>
-                        <a:t>57 – 63</a:t>
+                        <a:t>63</a:t>
                       </a:r>
                     </a:p>
                   </a:txBody>
@@ -13669,7 +13670,7 @@
                           </a:solidFill>
                           <a:latin typeface="Calibri"/>
                         </a:rPr>
-                        <a:t>125 – 368</a:t>
+                        <a:t>201 – 214</a:t>
                       </a:r>
                     </a:p>
                   </a:txBody>
@@ -13717,7 +13718,7 @@
                           </a:solidFill>
                           <a:latin typeface="Calibri"/>
                         </a:rPr>
-                        <a:t>832 – 900</a:t>
+                        <a:t>844 – 898</a:t>
                       </a:r>
                     </a:p>
                   </a:txBody>
@@ -13740,7 +13741,7 @@
                           </a:solidFill>
                           <a:latin typeface="Calibri"/>
                         </a:rPr>
-                        <a:t>438 – 681</a:t>
+                        <a:t>514 – 527</a:t>
                       </a:r>
                     </a:p>
                   </a:txBody>
@@ -13788,7 +13789,7 @@
                           </a:solidFill>
                           <a:latin typeface="Calibri"/>
                         </a:rPr>
-                        <a:t>$0.0020 – 0.0022</a:t>
+                        <a:t>$0.0021 – 0.0022</a:t>
                       </a:r>
                     </a:p>
                   </a:txBody>
@@ -13811,7 +13812,7 @@
                           </a:solidFill>
                           <a:latin typeface="Calibri"/>
                         </a:rPr>
-                        <a:t>$0.00033 – 0.00081</a:t>
+                        <a:t>$0.00048 – 0.00051</a:t>
                       </a:r>
                     </a:p>
                   </a:txBody>
@@ -13876,7 +13877,7 @@
                 </a:solidFill>
                 <a:latin typeface="Calibri"/>
               </a:rPr>
-              <a:t>Same five tasks: gpt-4.1 costs 4.1× gpt-5-mini</a:t>
+              <a:t>Same five tasks: gpt-4.1 costs 4.6× gpt-5-mini</a:t>
             </a:r>
           </a:p>
           <a:p>
@@ -13888,7 +13889,7 @@
                 </a:solidFill>
                 <a:latin typeface="Calibri"/>
               </a:rPr>
-              <a:t>Mean of its 2 legs against gpt-5-mini's 7; leg-to-leg the ratio spans 2.5×–6.7×, because gpt-5-mini's output length swings with reasoning effort. The reasoning model answers in ONE call; gpt-4.1 needs ~3 tool round-trips. On our card the INPUT side decides it alone — 2.6× the tokens at 8× the price is a 21× input bill, and the output side cannot offset it (gpt-5-mini emits 3.6× more output at a quarter the rate, so the two output bills land within 10% of each other).</a:t>
+              <a:t>Mean of its 2 legs against gpt-5-mini's 8; leg-to-leg the ratio spans 3.3×–6.6×, because gpt-5-mini's output length swings with reasoning effort. The reasoning model answers in ONE call; gpt-4.1 needs ~3 tool round-trips. On our card the INPUT side decides it alone — 2.6× the tokens at 8× the price is a 21× input bill, and the output side cannot offset it (gpt-5-mini emits 3.3× more output at a quarter the rate, so the two output bills land within 24% of each other).</a:t>
             </a:r>
           </a:p>
         </p:txBody>
@@ -13943,7 +13944,7 @@
                 </a:solidFill>
                 <a:latin typeface="Calibri"/>
               </a:rPr>
-              <a:t>cost per task  =  (input tokens × P_in  +  output tokens × P_out) / 1 M     — which model is cheaper is a property of the PRICE LIST, not of the models: compute it for your own rates.  Money AMPLIFIES the difficulty ladder rather than tracking it (tau2 178× a gsm8k task in tokens but 279× in dollars; appworld 564× but 1,069×), because the harder benchmarks also run the dearer models — a budget scaled off the token ratios is short by 1.6–1.9×.</a:t>
+              <a:t>cost per task  =  (input tokens × P_in  +  output tokens × P_out) / 1 M     — which model is cheaper is a property of the PRICE LIST, not of the models: compute it for your own rates.  Money AMPLIFIES the difficulty ladder rather than tracking it (tau2 175× a gsm8k task in tokens but 282× in dollars; appworld 621× but 1,195×), because the harder benchmarks also run the dearer models — a budget scaled off the token ratios is short by 1.6–1.9×.</a:t>
             </a:r>
           </a:p>
         </p:txBody>
@@ -14928,7 +14929,7 @@
                 </a:solidFill>
                 <a:latin typeface="Calibri"/>
               </a:rPr>
-              <a:t>The judge makes ~1 completion per authorized tool call, on Azure/gpt-4.1 — the dearest model on the card — against a FIXED 1,577-char system prompt that does not shrink with the task. That is ≥ $0.00111 per call, which is 2.4× the entire gsm8k task it is authorizing ($0.00045), and 1.4×–4.4× the agent's whole bill across legs #6–#8. On the plugin legs IBAC is not overhead on the bill; it IS the bill.  tau2's user simulator is invisible the same way: same model as the agent, but inside the uninstrumented MCP pod.</a:t>
+              <a:t>The judge makes ~1 completion per authorized tool call, on Azure/gpt-4.1 — the dearest model on the card — against a FIXED 1,577-char system prompt that does not shrink with the task. That is ≥ $0.00111 per call, which is 2.6× the entire gsm8k task it is authorizing ($0.00043), and 1.7×–3.4× the agent's whole bill across legs #6–#8. On the plugin legs IBAC is not overhead on the bill; it IS the bill.  tau2's user simulator is invisible the same way: same model as the agent, but inside the uninstrumented MCP pod.</a:t>
             </a:r>
           </a:p>
         </p:txBody>
@@ -14995,7 +14996,7 @@
                 </a:solidFill>
                 <a:latin typeface="Calibri"/>
               </a:rPr>
-              <a:t>The gateway REPORTS cached input (usage.prompt_tokens_details.cached_tokens, verified by probe) but publishes no cached-input rate, and report.ndjson stores one undifferentiated llm_input_tokens — so no past run can be re-priced. The exposure is capped by input's share of the bill: if cached input were FREE, tau2 would floor at $0.0157 a task instead of $0.154 and appworld at $0.251 instead of $0.589, while gsm8k barely moves. That ordering is structural — caching pays off on a long re-sent prefix, which is what makes input dominate.</a:t>
+              <a:t>The gateway REPORTS cached input (usage.prompt_tokens_details.cached_tokens, verified by probe) but publishes no cached-input rate, and report.ndjson stores one undifferentiated llm_input_tokens — so no past run can be re-priced. The exposure is capped by input's share of the bill: if cached input were FREE, tau2 would floor at $0.0157 a task instead of $0.149 and appworld at $0.270 instead of $0.634, while gsm8k barely moves. That ordering is structural — caching pays off on a long re-sent prefix, which is what makes input dominate.</a:t>
             </a:r>
           </a:p>
         </p:txBody>
@@ -16603,7 +16604,7 @@
                 </a:solidFill>
                 <a:latin typeface="Calibri"/>
               </a:rPr>
-              <a:t>Measured on the v1.28 pair (267 task rows) at the rate card in 7.7 — one take-away per figure</a:t>
+              <a:t>Measured on the v1.35 pair (281 task rows) at the rate card in 7.7 — one take-away per figure</a:t>
             </a:r>
           </a:p>
         </p:txBody>
@@ -16694,7 +16695,7 @@
                 </a:solidFill>
                 <a:latin typeface="Calibri"/>
               </a:rPr>
-              <a:t>Money climbs the difficulty ladder faster than tokens do: tau2 is 178× a gsm8k task in tokens but 279× in dollars, appworld is 564× a gsm8k task in tokens but 1,069× in dollars — so a budget scaled off the token ratios is short by 1.6–1.9×.</a:t>
+              <a:t>Money climbs the difficulty ladder faster than tokens do: tau2 is 175× a gsm8k task in tokens but 282× in dollars, appworld is 621× a gsm8k task in tokens but 1,195× in dollars — so a budget scaled off the token ratios is short by 1.6–1.9×.</a:t>
             </a:r>
           </a:p>
         </p:txBody>
@@ -16785,7 +16786,7 @@
                 </a:solidFill>
                 <a:latin typeface="Calibri"/>
               </a:rPr>
-              <a:t>Output is priced 4–8× input on every model we use, so the token split misstates the bill every time: gsm8k on gpt-5-mini is 63% input by tokens and only 17% by cost.</a:t>
+              <a:t>Output is priced 4–8× input on every model we use, so the token split misstates the bill every time: gsm8k on gpt-5-mini is 64% input by tokens and only 18% by cost.</a:t>
             </a:r>
           </a:p>
         </p:txBody>
@@ -16807,7 +16808,7 @@
         <p:spPr>
           <a:xfrm>
             <a:off x="8183879" y="1234440"/>
-            <a:ext cx="3611880" cy="1756890"/>
+            <a:ext cx="3611880" cy="1774415"/>
           </a:xfrm>
           <a:prstGeom prst="rect">
             <a:avLst/>
@@ -16822,7 +16823,7 @@
         </p:nvSpPr>
         <p:spPr>
           <a:xfrm>
-            <a:off x="8183879" y="3082770"/>
+            <a:off x="8183879" y="3100295"/>
             <a:ext cx="3611880" cy="2148840"/>
           </a:xfrm>
           <a:prstGeom prst="roundRect">
@@ -16876,7 +16877,7 @@
                 </a:solidFill>
                 <a:latin typeface="Calibri"/>
               </a:rPr>
-              <a:t>gpt-4.1 costs 4.1× gpt-5-mini on the identical 5 gsm8k tasks, and the input side decides it alone: 21× the input bill, against an output bill the two models split within 10%.</a:t>
+              <a:t>gpt-4.1 costs 4.6× gpt-5-mini on the identical 5 gsm8k tasks, and the input side decides it alone: 21× the input bill, against an output bill the two models split within 24%.</a:t>
             </a:r>
           </a:p>
         </p:txBody>
@@ -17088,7 +17089,7 @@
                 </a:solidFill>
                 <a:latin typeface="Calibri"/>
               </a:rPr>
-              <a:t>Two of the twelve legs are 76% of a matrix's bill, while all 8 gsm8k legs together are 0.2% of it — so budget by benchmark, not by task count.</a:t>
+              <a:t>Two of the twelve legs are 78% of a matrix's bill, while all 8 gsm8k legs together are 0.2% of it — so budget by benchmark, not by task count.</a:t>
             </a:r>
           </a:p>
         </p:txBody>
@@ -17110,7 +17111,7 @@
         <p:spPr>
           <a:xfrm>
             <a:off x="4297680" y="1234440"/>
-            <a:ext cx="3611880" cy="2080492"/>
+            <a:ext cx="3611880" cy="2092865"/>
           </a:xfrm>
           <a:prstGeom prst="rect">
             <a:avLst/>
@@ -17125,7 +17126,7 @@
         </p:nvSpPr>
         <p:spPr>
           <a:xfrm>
-            <a:off x="4297680" y="3406372"/>
+            <a:off x="4297680" y="3418745"/>
             <a:ext cx="3611880" cy="2148840"/>
           </a:xfrm>
           <a:prstGeom prst="roundRect">
@@ -17179,7 +17180,7 @@
                 </a:solidFill>
                 <a:latin typeface="Calibri"/>
               </a:rPr>
-              <a:t>Dividing by the pass rate is what turns a token count into an efficiency figure: gsm8k $0.00055 per task becomes $0.00056 per PASS; tau2 $0.1538 per task becomes $0.1846 per PASS — and appworld has no finite cost per success at all, because it passed nothing.</a:t>
+              <a:t>Dividing by the pass rate is what turns a token count into an efficiency figure: gsm8k $0.00053 per task becomes $0.00054 per PASS; tau2 $0.1494 per task becomes $0.1660 per PASS — and appworld has no finite cost per success at all, because it passed nothing.</a:t>
             </a:r>
           </a:p>
         </p:txBody>
@@ -17201,7 +17202,7 @@
         <p:spPr>
           <a:xfrm>
             <a:off x="8183879" y="1234440"/>
-            <a:ext cx="3611880" cy="2099443"/>
+            <a:ext cx="3611880" cy="2035312"/>
           </a:xfrm>
           <a:prstGeom prst="rect">
             <a:avLst/>
@@ -17216,7 +17217,7 @@
         </p:nvSpPr>
         <p:spPr>
           <a:xfrm>
-            <a:off x="8183879" y="3425323"/>
+            <a:off x="8183879" y="3361192"/>
             <a:ext cx="3611880" cy="2148840"/>
           </a:xfrm>
           <a:prstGeom prst="roundRect">
@@ -17270,7 +17271,7 @@
                 </a:solidFill>
                 <a:latin typeface="Calibri"/>
               </a:rPr>
-              <a:t>One IBAC judge completion costs at least $0.00111 — 2.4× the entire gsm8k task on gpt-5-mini it is authorizing — so across legs #6/#7/#8 the judge bills 1.4–4.4× what the agent does.</a:t>
+              <a:t>One IBAC judge completion costs at least $0.00111 — 2.6× the entire gsm8k task on gpt-5-mini it is authorizing — so across legs #6/#7/#8 the judge bills 1.7–3.4× what the agent does.</a:t>
             </a:r>
           </a:p>
         </p:txBody>
@@ -18996,7 +18997,7 @@
                 </a:solidFill>
                 <a:latin typeface="Calibri"/>
               </a:rPr>
-              <a:t>Why a FIXED matrix: task selection is deterministic, so the same leg run anywhere executes the same tasks in the same order. That is what makes a difference attributable to the platform rather than to the workload. Every leg deploys fresh — originally because a warm agent lost telemetry (fixed in agent dev145), now because only a NEWLY CREATED pod re-pulls :latest. Driven by one command (reference/run-12.py): ~1h35m of leg wall time per platform, plus the deploys and ~33 min of gateway-cache gaps. The generated documents in docs/results/ derive every number from the mirrored artifacts.</a:t>
+              <a:t>Why a FIXED matrix: task selection is deterministic, so the same leg run anywhere executes the same tasks in the same order. That is what makes a difference attributable to the platform rather than to the workload. Every leg deploys fresh, because only a NEWLY CREATED pod re-pulls :latest. Driven by one command (reference/run-12.py): about an hour of run time per platform, plus the deploys and ~40 min of gateway-cache gaps. The generated documents in docs/results/ derive every number from the mirrored artifacts.</a:t>
             </a:r>
           </a:p>
         </p:txBody>
@@ -19277,7 +19278,7 @@
                           </a:solidFill>
                           <a:latin typeface="Calibri"/>
                         </a:rPr>
-                        <a:t>the pipeline is stable and DETERMINISTIC: 6 of 12 legs have byte-identical input-token
+                        <a:t>the pipeline is stable and DETERMINISTIC: 7 of 12 legs have byte-identical input-token
 totals across two unlike clusters — the strongest like-for-like check available</a:t>
                       </a:r>
                     </a:p>
@@ -19350,7 +19351,7 @@
                           </a:solidFill>
                           <a:latin typeface="Calibri"/>
                         </a:rPr>
-                        <a:t>the only clean model comparison in the matrix: gpt-4.1 costs 4.1× gpt-5-mini for no
+                        <a:t>the only clean model comparison in the matrix: gpt-4.1 costs 4.6× gpt-5-mini for no
 pass-rate gain at this difficulty, and the INPUT side decides it alone (7.7)</a:t>
                       </a:r>
                     </a:p>
@@ -19423,8 +19424,8 @@
                           </a:solidFill>
                           <a:latin typeface="Calibri"/>
                         </a:rPr>
-                        <a:t>plugin cost is PLATFORM-SPECIFIC: OpenShift pays in the sidecar (+13.68 s/task), KinD in
-the judge (+1.54 s) — never quote a per-task overhead without naming the cluster</a:t>
+                        <a:t>plugin cost lands in the IBAC JUDGE on both clusters: +1.36 s/task on OpenShift, +1.48 s
+on KinD — the sidecar and every other layer are below the noise floor (9.2)</a:t>
                       </a:r>
                     </a:p>
                   </a:txBody>
@@ -19497,7 +19498,7 @@
                           <a:latin typeface="Calibri"/>
                         </a:rPr>
                         <a:t>multi-turn works end to end, user simulator included — and tau2 is where pass rates
-carry information (0.75–1.00 across sides)</a:t>
+carry information (0.85–1.00 across sides)</a:t>
                       </a:r>
                     </a:p>
                   </a:txBody>
@@ -19569,8 +19570,8 @@
                           </a:solidFill>
                           <a:latin typeface="Calibri"/>
                         </a:rPr>
-                        <a:t>the limits are real and they are UPSTREAM: 15 timeouts, a 0.00 pass rate, and 76% of
-the whole matrix's bill in two legs</a:t>
+                        <a:t>the limits are real and they are UPSTREAM: a 0.00 pass rate, the matrix's only timeout,
+and ~77% of the whole matrix's bill in two legs</a:t>
                       </a:r>
                     </a:p>
                   </a:txBody>
@@ -19647,7 +19648,7 @@
                 </a:solidFill>
                 <a:latin typeface="Calibri"/>
               </a:rPr>
-              <a:t>Not the pass rates — that the SAME 12 request bodies produce comparable measurements on two unlike clusters. On the v1.28 pair: token capture complete (0 of 267 rows lost their usage span), every task reached the model (0 health-probe losses), 7 of 12 pass rates identical. The 5 that differ are mostly arithmetic on small runs — one task moves a 5-task leg by 0.20.</a:t>
+              <a:t>Not the pass rates — that the SAME 12 request bodies produce comparable measurements on two unlike clusters. On the v1.35 pair: token capture complete (0 of 281 rows lost their usage span), every task reached the model (0 health-probe losses), nothing lost to infrastructure, 8 of 12 pass rates identical. The 4 that differ are each one task — one task moves a 5-task leg by 0.20.</a:t>
             </a:r>
           </a:p>
         </p:txBody>
@@ -19714,7 +19715,7 @@
                 </a:solidFill>
                 <a:latin typeface="Calibri"/>
               </a:rPr>
-              <a:t>A task lost to a socket and a task lost to a wrong answer land in the same denominator and only one says anything about the agent — which is why every report buckets them (OCP/KinD: transport 1/0, per-task timeout 4/11, upstream agent defect 1/0, wrong answer 2/1). Two further limits: absolute LATENCY does not travel (4–93× apart between our clusters), and the DEPLOY, not the task, is the unit of replication — adding tasks tightens the wrong interval.</a:t>
+              <a:t>A task lost to a socket and a task lost to a wrong answer land in the same denominator and only one says anything about the agent — which is why every report buckets them (OCP/KinD: per-task timeout 0/1, upstream agent defect 4/4, wrong answer 1/1). Two further limits: absolute LATENCY travels only approximately (up to 1.7× apart between our clusters), and the DEPLOY, not the task, is the unit of replication — adding tasks tightens the wrong interval.</a:t>
             </a:r>
           </a:p>
         </p:txBody>
@@ -19835,7 +19836,7 @@
                 </a:solidFill>
                 <a:latin typeface="Calibri"/>
               </a:rPr>
-              <a:t>v1.28 on OpenShift (Service on ykt3, workloads on ykt2) — 141 tasks, all 12 legs succeeded</a:t>
+              <a:t>v1.35 on OpenShift (single-cluster, ykt3) — 141 tasks, all 12 legs succeeded</a:t>
             </a:r>
           </a:p>
         </p:txBody>
@@ -20112,7 +20113,7 @@
                           </a:solidFill>
                           <a:latin typeface="Calibri"/>
                         </a:rPr>
-                        <a:t>7 s</a:t>
+                        <a:t>4 s</a:t>
                       </a:r>
                     </a:p>
                   </a:txBody>
@@ -20252,7 +20253,7 @@
                           </a:solidFill>
                           <a:latin typeface="Calibri"/>
                         </a:rPr>
-                        <a:t>41 s</a:t>
+                        <a:t>29 s</a:t>
                       </a:r>
                     </a:p>
                   </a:txBody>
@@ -20392,7 +20393,7 @@
                           </a:solidFill>
                           <a:latin typeface="Calibri"/>
                         </a:rPr>
-                        <a:t>46 s</a:t>
+                        <a:t>34 s</a:t>
                       </a:r>
                     </a:p>
                   </a:txBody>
@@ -20532,7 +20533,7 @@
                           </a:solidFill>
                           <a:latin typeface="Calibri"/>
                         </a:rPr>
-                        <a:t>16 s</a:t>
+                        <a:t>9 s</a:t>
                       </a:r>
                     </a:p>
                   </a:txBody>
@@ -20555,7 +20556,7 @@
                           </a:solidFill>
                           <a:latin typeface="Calibri"/>
                         </a:rPr>
-                        <a:t>3,874</a:t>
+                        <a:t>3,908</a:t>
                       </a:r>
                     </a:p>
                   </a:txBody>
@@ -20672,7 +20673,7 @@
                           </a:solidFill>
                           <a:latin typeface="Calibri"/>
                         </a:rPr>
-                        <a:t>25 s</a:t>
+                        <a:t>6 s</a:t>
                       </a:r>
                     </a:p>
                   </a:txBody>
@@ -20766,7 +20767,7 @@
                           </a:solidFill>
                           <a:latin typeface="Calibri"/>
                         </a:rPr>
-                        <a:t>0.60</a:t>
+                        <a:t>1.00</a:t>
                       </a:r>
                     </a:p>
                   </a:txBody>
@@ -20789,7 +20790,7 @@
                           </a:solidFill>
                           <a:latin typeface="Calibri"/>
                         </a:rPr>
-                        <a:t>2/5</a:t>
+                        <a:t>0/5</a:t>
                       </a:r>
                     </a:p>
                   </a:txBody>
@@ -20812,7 +20813,7 @@
                           </a:solidFill>
                           <a:latin typeface="Calibri"/>
                         </a:rPr>
-                        <a:t>39 s</a:t>
+                        <a:t>6 s</a:t>
                       </a:r>
                     </a:p>
                   </a:txBody>
@@ -20835,7 +20836,7 @@
                           </a:solidFill>
                           <a:latin typeface="Calibri"/>
                         </a:rPr>
-                        <a:t>1,258</a:t>
+                        <a:t>1,564</a:t>
                       </a:r>
                     </a:p>
                   </a:txBody>
@@ -20952,7 +20953,7 @@
                           </a:solidFill>
                           <a:latin typeface="Calibri"/>
                         </a:rPr>
-                        <a:t>30 s</a:t>
+                        <a:t>9 s</a:t>
                       </a:r>
                     </a:p>
                   </a:txBody>
@@ -21092,7 +21093,7 @@
                           </a:solidFill>
                           <a:latin typeface="Calibri"/>
                         </a:rPr>
-                        <a:t>23 s</a:t>
+                        <a:t>7 s</a:t>
                       </a:r>
                     </a:p>
                   </a:txBody>
@@ -21232,7 +21233,7 @@
                           </a:solidFill>
                           <a:latin typeface="Calibri"/>
                         </a:rPr>
-                        <a:t>803 s</a:t>
+                        <a:t>511 s</a:t>
                       </a:r>
                     </a:p>
                   </a:txBody>
@@ -21255,7 +21256,7 @@
                           </a:solidFill>
                           <a:latin typeface="Calibri"/>
                         </a:rPr>
-                        <a:t>988,110</a:t>
+                        <a:t>936,612</a:t>
                       </a:r>
                     </a:p>
                   </a:txBody>
@@ -21326,7 +21327,7 @@
                           </a:solidFill>
                           <a:latin typeface="Calibri"/>
                         </a:rPr>
-                        <a:t>0.75</a:t>
+                        <a:t>0.90</a:t>
                       </a:r>
                     </a:p>
                   </a:txBody>
@@ -21372,7 +21373,7 @@
                           </a:solidFill>
                           <a:latin typeface="Calibri"/>
                         </a:rPr>
-                        <a:t>436 s</a:t>
+                        <a:t>282 s</a:t>
                       </a:r>
                     </a:p>
                   </a:txBody>
@@ -21395,7 +21396,7 @@
                           </a:solidFill>
                           <a:latin typeface="Calibri"/>
                         </a:rPr>
-                        <a:t>1,703,460</a:t>
+                        <a:t>1,695,959</a:t>
                       </a:r>
                     </a:p>
                   </a:txBody>
@@ -21489,7 +21490,7 @@
                           </a:solidFill>
                           <a:latin typeface="Calibri"/>
                         </a:rPr>
-                        <a:t>2/5</a:t>
+                        <a:t>1/5</a:t>
                       </a:r>
                     </a:p>
                   </a:txBody>
@@ -21512,7 +21513,7 @@
                           </a:solidFill>
                           <a:latin typeface="Calibri"/>
                         </a:rPr>
-                        <a:t>2433 s</a:t>
+                        <a:t>1284 s</a:t>
                       </a:r>
                     </a:p>
                   </a:txBody>
@@ -21535,7 +21536,7 @@
                           </a:solidFill>
                           <a:latin typeface="Calibri"/>
                         </a:rPr>
-                        <a:t>1,387,383</a:t>
+                        <a:t>1,420,531</a:t>
                       </a:r>
                     </a:p>
                   </a:txBody>
@@ -21652,7 +21653,7 @@
                           </a:solidFill>
                           <a:latin typeface="Calibri"/>
                         </a:rPr>
-                        <a:t>1818 s</a:t>
+                        <a:t>1402 s</a:t>
                       </a:r>
                     </a:p>
                   </a:txBody>
@@ -21675,7 +21676,7 @@
                           </a:solidFill>
                           <a:latin typeface="Calibri"/>
                         </a:rPr>
-                        <a:t>5,211,584</a:t>
+                        <a:t>5,949,228</a:t>
                       </a:r>
                     </a:p>
                   </a:txBody>
@@ -21740,7 +21741,7 @@
                 </a:solidFill>
                 <a:latin typeface="Calibri"/>
               </a:rPr>
-              <a:t>gsm8k does not quite saturate here: 5 of 8 legs at 1.00</a:t>
+              <a:t>gsm8k nearly saturates: 6 of 8 legs at 1.00</a:t>
             </a:r>
           </a:p>
           <a:p>
@@ -21752,7 +21753,7 @@
                 </a:solidFill>
                 <a:latin typeface="Calibri"/>
               </a:rPr>
-              <a:t>#4's gpt-4.1 swap and #7 lose one task of five, #6 two — five of 86. Read the CAUSE, not the rate: one of #6's was a dropped socket, not the model. The runner retries those now.</a:t>
+              <a:t>#4's gpt-4.1 swap and #7 each lose one task of five — two of 86, both the model's own answers. Read the CAUSE, not the rate: nothing on this side was lost to the plumbing.</a:t>
             </a:r>
           </a:p>
         </p:txBody>
@@ -21819,7 +21820,7 @@
                 </a:solidFill>
                 <a:latin typeface="Calibri"/>
               </a:rPr>
-              <a:t>0.90 and 0.75 here, 1.00 and 0.80 on KinD. Episodes are nondeterministic: at n=10 one task is worth 0.10, so it cannot resolve less.</a:t>
+              <a:t>0.90 and 0.90 here, 1.00 and 0.85 on KinD. Episodes are nondeterministic: at n=10 one task is worth 0.10, so it cannot resolve less.</a:t>
             </a:r>
           </a:p>
         </p:txBody>
@@ -21886,7 +21887,7 @@
                 </a:solidFill>
                 <a:latin typeface="Calibri"/>
               </a:rPr>
-              <a:t>Runs complete, tokens record, evaluation says the goal was not met — 34 of 35 tasks self-declare finish. The per-task TIMEOUT dominates: 4 of 25 tasks left no report row, so err reads run.json.</a:t>
+              <a:t>Runs complete, tokens record, evaluation says the goal was not met — most tasks self-declare finish (41 of 49, both platforms). All 4 errors here are the agent's own defect; none hit the 600 s timeout. err reads run.json.</a:t>
             </a:r>
           </a:p>
         </p:txBody>
@@ -21941,7 +21942,7 @@
                 </a:solidFill>
                 <a:latin typeface="Calibri"/>
               </a:rPr>
-              <a:t>0 rows lost attribution, 0 tasks lost to the health probe</a:t>
+              <a:t>0 rows lost attribution, 0 tasks lost to infrastructure</a:t>
             </a:r>
           </a:p>
           <a:p>
@@ -21953,7 +21954,7 @@
                 </a:solidFill>
                 <a:latin typeface="Calibri"/>
               </a:rPr>
-              <a:t>The dev145 agent's per-task GET /v1/models probe (10 s cap, no retry) killed 12 of 141 KinD tasks; dev146 fixed it. An earlier matrix's 15 damaged rows passed a tokens == 0 check as clean — hence the structural detector.</a:t>
+              <a:t>No task died to the health probe, the gateway, the judge or transport. v1.35 caps each agent LLM call at 120 s, so a stalled gateway call is cut and retried, not waited out.</a:t>
             </a:r>
           </a:p>
         </p:txBody>
@@ -22008,7 +22009,7 @@
                 </a:solidFill>
                 <a:latin typeface="Calibri"/>
               </a:rPr>
-              <a:t>9.3M input / 683k output tokens</a:t>
+              <a:t>10.0M input / 728k output tokens</a:t>
             </a:r>
           </a:p>
           <a:p>
@@ -22020,7 +22021,7 @@
                 </a:solidFill>
                 <a:latin typeface="Calibri"/>
               </a:rPr>
-              <a:t>over 5,719 s of leg wall time — appworld alone is 71% of the input, on 21 of 137 rows.</a:t>
+              <a:t>over 3,583 s of run time — appworld alone is 73% of the input, on 25 of 141 rows.</a:t>
             </a:r>
           </a:p>
         </p:txBody>
@@ -22908,7 +22909,7 @@
                           </a:solidFill>
                           <a:latin typeface="Calibri"/>
                         </a:rPr>
-                        <a:t>1.00</a:t>
+                        <a:t>0.80</a:t>
                       </a:r>
                     </a:p>
                   </a:txBody>
@@ -22931,7 +22932,7 @@
                           </a:solidFill>
                           <a:latin typeface="Calibri"/>
                         </a:rPr>
-                        <a:t>3,874</a:t>
+                        <a:t>3,908</a:t>
                       </a:r>
                     </a:p>
                   </a:txBody>
@@ -22954,7 +22955,7 @@
                           </a:solidFill>
                           <a:latin typeface="Calibri"/>
                         </a:rPr>
-                        <a:t>4,183</a:t>
+                        <a:t>4,177</a:t>
                       </a:r>
                     </a:p>
                   </a:txBody>
@@ -23211,7 +23212,7 @@
                           </a:solidFill>
                           <a:latin typeface="Calibri"/>
                         </a:rPr>
-                        <a:t>0.60</a:t>
+                        <a:t>1.00</a:t>
                       </a:r>
                     </a:p>
                   </a:txBody>
@@ -23257,7 +23258,7 @@
                           </a:solidFill>
                           <a:latin typeface="Calibri"/>
                         </a:rPr>
-                        <a:t>1,258</a:t>
+                        <a:t>1,564</a:t>
                       </a:r>
                     </a:p>
                   </a:txBody>
@@ -23303,7 +23304,7 @@
                           </a:solidFill>
                           <a:latin typeface="Calibri"/>
                         </a:rPr>
-                        <a:t/>
+                        <a:t>identical</a:t>
                       </a:r>
                     </a:p>
                   </a:txBody>
@@ -23746,7 +23747,7 @@
                           </a:solidFill>
                           <a:latin typeface="Calibri"/>
                         </a:rPr>
-                        <a:t>988,110</a:t>
+                        <a:t>936,612</a:t>
                       </a:r>
                     </a:p>
                   </a:txBody>
@@ -23769,7 +23770,7 @@
                           </a:solidFill>
                           <a:latin typeface="Calibri"/>
                         </a:rPr>
-                        <a:t>1,019,232</a:t>
+                        <a:t>916,576</a:t>
                       </a:r>
                     </a:p>
                   </a:txBody>
@@ -23863,7 +23864,7 @@
                           </a:solidFill>
                           <a:latin typeface="Calibri"/>
                         </a:rPr>
-                        <a:t>0.75</a:t>
+                        <a:t>0.90</a:t>
                       </a:r>
                     </a:p>
                   </a:txBody>
@@ -23886,7 +23887,7 @@
                           </a:solidFill>
                           <a:latin typeface="Calibri"/>
                         </a:rPr>
-                        <a:t>0.80</a:t>
+                        <a:t>0.85</a:t>
                       </a:r>
                     </a:p>
                   </a:txBody>
@@ -23909,7 +23910,7 @@
                           </a:solidFill>
                           <a:latin typeface="Calibri"/>
                         </a:rPr>
-                        <a:t>1,703,460</a:t>
+                        <a:t>1,695,959</a:t>
                       </a:r>
                     </a:p>
                   </a:txBody>
@@ -23932,7 +23933,7 @@
                           </a:solidFill>
                           <a:latin typeface="Calibri"/>
                         </a:rPr>
-                        <a:t>1,743,312</a:t>
+                        <a:t>1,726,957</a:t>
                       </a:r>
                     </a:p>
                   </a:txBody>
@@ -24072,7 +24073,7 @@
                           </a:solidFill>
                           <a:latin typeface="Calibri"/>
                         </a:rPr>
-                        <a:t>1,387,383</a:t>
+                        <a:t>1,420,531</a:t>
                       </a:r>
                     </a:p>
                   </a:txBody>
@@ -24095,7 +24096,7 @@
                           </a:solidFill>
                           <a:latin typeface="Calibri"/>
                         </a:rPr>
-                        <a:t>840,030</a:t>
+                        <a:t>1,564,276</a:t>
                       </a:r>
                     </a:p>
                   </a:txBody>
@@ -24235,7 +24236,7 @@
                           </a:solidFill>
                           <a:latin typeface="Calibri"/>
                         </a:rPr>
-                        <a:t>5,211,584</a:t>
+                        <a:t>5,949,228</a:t>
                       </a:r>
                     </a:p>
                   </a:txBody>
@@ -24258,7 +24259,7 @@
                           </a:solidFill>
                           <a:latin typeface="Calibri"/>
                         </a:rPr>
-                        <a:t>2,009,348</a:t>
+                        <a:t>5,349,900</a:t>
                       </a:r>
                     </a:p>
                   </a:txBody>
@@ -24346,7 +24347,7 @@
                 </a:solidFill>
                 <a:latin typeface="Calibri"/>
               </a:rPr>
-              <a:t>7 of 12 pass rates identical, and all 5 deltas favour KinD</a:t>
+              <a:t>8 of 12 pass rates identical; the 4 deltas split 2–2</a:t>
             </a:r>
           </a:p>
           <a:p>
@@ -24358,7 +24359,7 @@
                 </a:solidFill>
                 <a:latin typeface="Calibri"/>
               </a:rPr>
-              <a:t>So read the per-CAUSE table instead of the rate: wrong answers split 2 (OCP) to 1 (KinD), per-task timeouts 4 to 11 — all appworld — and one dropped socket, OCP #6.</a:t>
+              <a:t>Each is one task. The per-CAUSE table says why: wrong answers 1 to 1, agent defects 4 to 4, one appworld timeout on KinD — and nothing lost to infrastructure on either side.</a:t>
             </a:r>
           </a:p>
         </p:txBody>
@@ -24413,7 +24414,7 @@
                 </a:solidFill>
                 <a:latin typeface="Calibri"/>
               </a:rPr>
-              <a:t>6 legs byte-identical on input tokens</a:t>
+              <a:t>7 legs byte-identical on input tokens</a:t>
             </a:r>
           </a:p>
           <a:p>
@@ -24425,7 +24426,7 @@
                 </a:solidFill>
                 <a:latin typeface="Calibri"/>
               </a:rPr>
-              <a:t>320 / 3,166 / 15,684 / 1,564 x3. Deterministic task selection plus the same model means identical work — the strongest available proof this is a like-for-like comparison, not merely a similar one.</a:t>
+              <a:t>320 / 3,166 / 15,684 / 1,564 ×4. Deterministic task selection plus the same model means identical work — the strongest available proof this is a like-for-like comparison, not merely a similar one.</a:t>
             </a:r>
           </a:p>
         </p:txBody>
@@ -24480,7 +24481,7 @@
                 </a:solidFill>
                 <a:latin typeface="Calibri"/>
               </a:rPr>
-              <a:t>#7 is in that set at 0.80 vs 1.00</a:t>
+              <a:t>#6 and #7 are in that set with different pass rates</a:t>
             </a:r>
           </a:p>
           <a:p>
@@ -24547,7 +24548,7 @@
                 </a:solidFill>
                 <a:latin typeface="Calibri"/>
               </a:rPr>
-              <a:t>Wall time: 5,719 s OCP vs 5,975 s KinD</a:t>
+              <a:t>Wall time: 3,583 s OCP vs 3,791 s KinD</a:t>
             </a:r>
           </a:p>
           <a:p>
@@ -24559,7 +24560,7 @@
                 </a:solidFill>
                 <a:latin typeface="Calibri"/>
               </a:rPr>
-              <a:t>Within 5% overall, but individual legs differ by up to 2.3× in either direction, and appworld — which dominates the total — inverts: #11 is faster on KinD, #12 is slower.</a:t>
+              <a:t>Within 6% overall. The short gsm8k legs differ by up to 2× either way (seconds, mostly startup); the long tau2 and appworld legs stay within 15%.</a:t>
             </a:r>
           </a:p>
         </p:txBody>
@@ -24626,7 +24627,7 @@
                 </a:solidFill>
                 <a:latin typeface="Calibri"/>
               </a:rPr>
-              <a:t>137 OCP rows against 130 KinD. The 7-row gap is appworld tasks that timed out before the Service wrote a row (4 OCP, 11 KinD) — not lost telemetry.</a:t>
+              <a:t>141 OCP rows against 140 KinD. The one-row gap is a KinD appworld task that timed out before the Service wrote a row — not lost telemetry.</a:t>
             </a:r>
           </a:p>
         </p:txBody>
@@ -24680,7 +24681,7 @@
 
 <file path=ppt/slides/slide26.xml><?xml version="1.0" encoding="utf-8"?>
 <p:sld xmlns:a="http://schemas.openxmlformats.org/drawingml/2006/main" xmlns:p="http://schemas.openxmlformats.org/presentationml/2006/main" xmlns:r="http://schemas.openxmlformats.org/officeDocument/2006/relationships">
-  <p:cSld name="9.2 What AuthBridge Costs — and Why It Has No Single Number">
+  <p:cSld name="9.2 What AuthBridge Costs — Almost All of It Is the Judge">
     <p:spTree>
       <p:nvGrpSpPr>
         <p:cNvPr id="1" name=""/>
@@ -24736,7 +24737,7 @@
                 </a:solidFill>
                 <a:latin typeface="Calibri"/>
               </a:rPr>
-              <a:t>9.2  What AuthBridge Costs — and Why It Has No Single Number</a:t>
+              <a:t>9.2  What AuthBridge Costs — Almost All of It Is the Judge</a:t>
             </a:r>
           </a:p>
           <a:p>
@@ -24747,7 +24748,7 @@
                 </a:solidFill>
                 <a:latin typeface="Calibri"/>
               </a:rPr>
-              <a:t>The designed 13-leg experiment (n=50, crossover replicates, gateway cache spaced), v1.28</a:t>
+              <a:t>The designed 13-leg experiment (n=50, crossover replicates, gateway cache spaced), v1.35</a:t>
             </a:r>
           </a:p>
         </p:txBody>
@@ -24931,7 +24932,7 @@
                           </a:solidFill>
                           <a:latin typeface="Calibri"/>
                         </a:rPr>
-                        <a:t>0.423</a:t>
+                        <a:t>0.168</a:t>
                       </a:r>
                     </a:p>
                   </a:txBody>
@@ -24954,7 +24955,7 @@
                           </a:solidFill>
                           <a:latin typeface="Calibri"/>
                         </a:rPr>
-                        <a:t>0.099</a:t>
+                        <a:t>0.097</a:t>
                       </a:r>
                     </a:p>
                   </a:txBody>
@@ -25048,7 +25049,7 @@
                           </a:solidFill>
                           <a:latin typeface="Calibri"/>
                         </a:rPr>
-                        <a:t>14.101</a:t>
+                        <a:t>0.214</a:t>
                       </a:r>
                     </a:p>
                   </a:txBody>
@@ -25071,7 +25072,7 @@
                           </a:solidFill>
                           <a:latin typeface="Calibri"/>
                         </a:rPr>
-                        <a:t>0.152</a:t>
+                        <a:t>0.130</a:t>
                       </a:r>
                     </a:p>
                   </a:txBody>
@@ -25094,7 +25095,7 @@
                           </a:solidFill>
                           <a:latin typeface="Calibri"/>
                         </a:rPr>
-                        <a:t>+13.68</a:t>
+                        <a:t>+0.05</a:t>
                       </a:r>
                     </a:p>
                   </a:txBody>
@@ -25117,7 +25118,7 @@
                           </a:solidFill>
                           <a:latin typeface="Calibri"/>
                         </a:rPr>
-                        <a:t>+0.05</a:t>
+                        <a:t>+0.03</a:t>
                       </a:r>
                     </a:p>
                   </a:txBody>
@@ -25165,7 +25166,7 @@
                           </a:solidFill>
                           <a:latin typeface="Calibri"/>
                         </a:rPr>
-                        <a:t>14.148</a:t>
+                        <a:t>1.569</a:t>
                       </a:r>
                     </a:p>
                   </a:txBody>
@@ -25188,7 +25189,7 @@
                           </a:solidFill>
                           <a:latin typeface="Calibri"/>
                         </a:rPr>
-                        <a:t>1.688</a:t>
+                        <a:t>1.610</a:t>
                       </a:r>
                     </a:p>
                   </a:txBody>
@@ -25211,7 +25212,7 @@
                           </a:solidFill>
                           <a:latin typeface="Calibri"/>
                         </a:rPr>
-                        <a:t>+0.05</a:t>
+                        <a:t>+1.36</a:t>
                       </a:r>
                     </a:p>
                   </a:txBody>
@@ -25234,7 +25235,7 @@
                           </a:solidFill>
                           <a:latin typeface="Calibri"/>
                         </a:rPr>
-                        <a:t>+1.54</a:t>
+                        <a:t>+1.48</a:t>
                       </a:r>
                     </a:p>
                   </a:txBody>
@@ -25282,7 +25283,7 @@
                           </a:solidFill>
                           <a:latin typeface="Calibri"/>
                         </a:rPr>
-                        <a:t>14.446</a:t>
+                        <a:t>1.584</a:t>
                       </a:r>
                     </a:p>
                   </a:txBody>
@@ -25305,7 +25306,7 @@
                           </a:solidFill>
                           <a:latin typeface="Calibri"/>
                         </a:rPr>
-                        <a:t>1.824</a:t>
+                        <a:t>1.602</a:t>
                       </a:r>
                     </a:p>
                   </a:txBody>
@@ -25328,7 +25329,7 @@
                           </a:solidFill>
                           <a:latin typeface="Calibri"/>
                         </a:rPr>
-                        <a:t>+0.30</a:t>
+                        <a:t>+0.01</a:t>
                       </a:r>
                     </a:p>
                   </a:txBody>
@@ -25351,7 +25352,7 @@
                           </a:solidFill>
                           <a:latin typeface="Calibri"/>
                         </a:rPr>
-                        <a:t>+0.14</a:t>
+                        <a:t>−0.01</a:t>
                       </a:r>
                     </a:p>
                   </a:txBody>
@@ -25399,7 +25400,7 @@
                           </a:solidFill>
                           <a:latin typeface="Calibri"/>
                         </a:rPr>
-                        <a:t>14.598</a:t>
+                        <a:t>1.583</a:t>
                       </a:r>
                     </a:p>
                   </a:txBody>
@@ -25422,7 +25423,7 @@
                           </a:solidFill>
                           <a:latin typeface="Calibri"/>
                         </a:rPr>
-                        <a:t>1.826</a:t>
+                        <a:t>1.607</a:t>
                       </a:r>
                     </a:p>
                   </a:txBody>
@@ -25445,7 +25446,7 @@
                           </a:solidFill>
                           <a:latin typeface="Calibri"/>
                         </a:rPr>
-                        <a:t>+0.15</a:t>
+                        <a:t>−0.00</a:t>
                       </a:r>
                     </a:p>
                   </a:txBody>
@@ -25638,7 +25639,7 @@
                           </a:solidFill>
                           <a:latin typeface="Calibri"/>
                         </a:rPr>
-                        <a:t>the sidecar</a:t>
+                        <a:t>the judge</a:t>
                       </a:r>
                     </a:p>
                   </a:txBody>
@@ -25684,7 +25685,7 @@
                           </a:solidFill>
                           <a:latin typeface="Calibri"/>
                         </a:rPr>
-                        <a:t>NO</a:t>
+                        <a:t>YES</a:t>
                       </a:r>
                     </a:p>
                   </a:txBody>
@@ -25826,7 +25827,7 @@
                           </a:solidFill>
                           <a:latin typeface="Calibri"/>
                         </a:rPr>
-                        <a:t>0.90–0.98</a:t>
+                        <a:t>0.94–1.00</a:t>
                       </a:r>
                     </a:p>
                   </a:txBody>
@@ -25849,7 +25850,7 @@
                           </a:solidFill>
                           <a:latin typeface="Calibri"/>
                         </a:rPr>
-                        <a:t>0.90–0.98</a:t>
+                        <a:t>0.96–1.02</a:t>
                       </a:r>
                     </a:p>
                   </a:txBody>
@@ -25920,7 +25921,7 @@
                           </a:solidFill>
                           <a:latin typeface="Calibri"/>
                         </a:rPr>
-                        <a:t>0.31×</a:t>
+                        <a:t>1.66×</a:t>
                       </a:r>
                     </a:p>
                   </a:txBody>
@@ -25943,7 +25944,7 @@
                           </a:solidFill>
                           <a:latin typeface="Calibri"/>
                         </a:rPr>
-                        <a:t>2.49×</a:t>
+                        <a:t>2.01×</a:t>
                       </a:r>
                     </a:p>
                   </a:txBody>
@@ -25966,7 +25967,7 @@
                           </a:solidFill>
                           <a:latin typeface="Calibri"/>
                         </a:rPr>
-                        <a:t>NO</a:t>
+                        <a:t>PARTLY</a:t>
                       </a:r>
                     </a:p>
                   </a:txBody>
@@ -26014,7 +26015,7 @@
                           </a:solidFill>
                           <a:latin typeface="Calibri"/>
                         </a:rPr>
-                        <a:t>0.22 s</a:t>
+                        <a:t>0.02 s</a:t>
                       </a:r>
                     </a:p>
                   </a:txBody>
@@ -26037,7 +26038,7 @@
                           </a:solidFill>
                           <a:latin typeface="Calibri"/>
                         </a:rPr>
-                        <a:t>0.155 s</a:t>
+                        <a:t>0.12 s</a:t>
                       </a:r>
                     </a:p>
                   </a:txBody>
@@ -26060,7 +26061,7 @@
                           </a:solidFill>
                           <a:latin typeface="Calibri"/>
                         </a:rPr>
-                        <a:t>YES</a:t>
+                        <a:t>NO</a:t>
                       </a:r>
                     </a:p>
                   </a:txBody>
@@ -26219,7 +26220,7 @@
                 </a:solidFill>
                 <a:latin typeface="Calibri"/>
               </a:rPr>
-              <a:t>The two clusters disagree about WHICH layer costs anything</a:t>
+              <a:t>Both clusters put the cost in the JUDGE</a:t>
             </a:r>
           </a:p>
           <a:p>
@@ -26231,7 +26232,7 @@
                 </a:solidFill>
                 <a:latin typeface="Calibri"/>
               </a:rPr>
-              <a:t>On OpenShift the whole expense is the sidecar's mere presence and the judge is noise; on KinD the sidecar is nearly free and the judge is all of it. Both are right about their own cluster, and the same condition on the same image measures 4–93× apart. Never quote an absolute per-task plugin figure without naming the cluster.</a:t>
+              <a:t>+1.36 s/task on OpenShift, +1.48 s on KinD; the sidecar's presence costs 0.03–0.05 s and every other layer is noise. With the judge engaged the same condition lands within 3% on the two clusters (1.57 / 1.61 s). Still name the cluster: on KinD ~0.26 s of each judged call is the node's DNS being retried.</a:t>
             </a:r>
           </a:p>
         </p:txBody>
@@ -26298,7 +26299,7 @@
                 </a:solidFill>
                 <a:latin typeface="Calibri"/>
               </a:rPr>
-              <a:t>A timeout piles values on a round number. OpenShift's auth-only runs 8.05–17.93 s, SD 1.92, broad and unimodal: contention and queueing. On the quiet cluster the tail moves to full (median 1.82 s, max 14.00 s) because the judge is itself an LLM call — so the sidecar costs reproducibility, not only latency.</a:t>
+              <a:t>A timeout piles values on a round number. Judged tasks run 0.21–9.63 s (OpenShift) and 0.12–7.75 s (KinD) around a ~1.6 s median, no 0.1 s bin above 12%: variable latency. The tail is the judge, itself an LLM call — so engaging it costs reproducibility, not only latency.</a:t>
             </a:r>
           </a:p>
         </p:txBody>
@@ -26365,7 +26366,7 @@
                 </a:solidFill>
                 <a:latin typeface="Calibri"/>
               </a:rPr>
-              <a:t>Every gsm8k leg sends the SAME 50 prompts and the gateway replays completions for ~10 min: unspaced, later legs measure the cache, in run order — the shape of a plugin effect. BM_CACHE_GAP=900 spaces them. The check needs no statistics: the conditions NEST, so no sidecar leg can beat a sidecar-free one. Clear by 41.8× (OCP), 1.4× (KinD).</a:t>
+              <a:t>Every gsm8k leg sends the SAME 50 prompts and the gateway replays completions for ~10 min: unspaced, later legs measure the cache, in run order — the shape of a plugin effect. BM_CACHE_GAP=900 spaces them. The check needs no statistics: the conditions NEST, so no sidecar leg can beat a sidecar-free one. Clear by 1.3× on both clusters.</a:t>
             </a:r>
           </a:p>
         </p:txBody>
@@ -26432,7 +26433,7 @@
                 </a:solidFill>
                 <a:latin typeface="Calibri"/>
               </a:rPr>
-              <a:t>A per-task interval measures variance WITHIN one deploy. The honest floor is between two deploys of one condition, and it exceeds every step but the dominant layer — so presets cannot be RANKED at any task count; add deploys, not tasks. Cut the other way: at σ ≈ 0.23 s two deploys already resolve a 1 s effect, so the small steps are genuinely small rather than unresolved.</a:t>
+              <a:t>A per-task interval measures variance WITHIN one deploy. The honest floor is between two deploys of one condition, and it exceeds every step but the judge's — so presets cannot be RANKED at any task count; add deploys, not tasks. Cut the other way: at σ ≈ 0.02 s (OpenShift) and 0.13 s (KinD) two deploys already resolve a 1 s effect, so the small steps are genuinely small rather than unresolved.</a:t>
             </a:r>
           </a:p>
         </p:txBody>
@@ -27036,7 +27037,7 @@
                 </a:solidFill>
                 <a:latin typeface="Calibri"/>
               </a:rPr>
-              <a:t>Cluster-agnostic by construction: works on kind / vanilla k8s / OpenShift; cross-cluster runs use per-instance route templates + a reachable internal issuer.</a:t>
+              <a:t>Cluster-agnostic by construction: the same chart installs on KinD and OpenShift, with the Service and its workloads on one cluster.</a:t>
             </a:r>
           </a:p>
         </p:txBody>
@@ -27304,7 +27305,7 @@
                 </a:solidFill>
                 <a:latin typeface="Calibri"/>
               </a:rPr>
-              <a:t>• Easy to configure in-cluster &amp; cross-cluster benchmark runs</a:t>
+              <a:t>• Easy to install on a cluster and run against it: KinD or OpenShift</a:t>
             </a:r>
           </a:p>
           <a:p>
@@ -27822,7 +27823,7 @@
                 </a:solidFill>
                 <a:latin typeface="Calibri"/>
               </a:rPr>
-              <a:t>One file per issuer: Rossoctl URL, benchmarker cred, MLflow/S3, optional Keycloak backchannel + workload route templates.</a:t>
+              <a:t>One file per issuer: Rossoctl URL, benchmarker cred, MLflow/S3, optional Keycloak backchannel.</a:t>
             </a:r>
           </a:p>
         </p:txBody>
@@ -27956,7 +27957,7 @@
                 </a:solidFill>
                 <a:latin typeface="Calibri"/>
               </a:rPr>
-              <a:t>MLflow is co-located with the Service (per-service traces it emits + reads), not in the workload cluster; S3 is an external cloud service — the shared cross-service sink.</a:t>
+              <a:t>MLflow runs on the Service's own cluster (the traces it emits and reads); S3 is an external cloud service — the shared cross-cluster sink for results.</a:t>
             </a:r>
           </a:p>
         </p:txBody>

</xml_diff>

<commit_message>
State the deployment model: one install per cluster, all workloads in one namespace
The Admin Guide's §1 section now carries it as its heading, with what
that means concretely: the Service is one Helm release in
rossoctl-system, every agent and MCP server runs in `team1` (with its
own openai-secret/hf-secret and, on OpenShift, MLflow workspace), one
IBAC judge per cluster, and the Keycloak realm the Service acts in. It
also gives the two rules for sharing one install (never the same
benchmark into the same namespace at once; one measurement campaign at
a time) and how a second namespace is added.

The Developer Guide's opening bullets and the deck's overview and
enactment slides say the same, re-rendered.

Assisted-By: Claude Opus 5.5 <noreply@anthropic.com>
Signed-off-by: Rong Chang <rong@us.ibm.com>
</commit_message>
<xml_diff>
--- a/docs/AutoBench.pptx
+++ b/docs/AutoBench.pptx
@@ -3369,7 +3369,7 @@
                 </a:solidFill>
                 <a:latin typeface="Calibri"/>
               </a:rPr>
-              <a:t>Last modified 2026-10-05 20:12 EDT</a:t>
+              <a:t>Last modified 2026-10-05 21:16 EDT</a:t>
             </a:r>
           </a:p>
         </p:txBody>
@@ -27037,7 +27037,7 @@
                 </a:solidFill>
                 <a:latin typeface="Calibri"/>
               </a:rPr>
-              <a:t>Cluster-agnostic by construction: the same chart installs on KinD and OpenShift, with the Service and its workloads on one cluster.</a:t>
+              <a:t>One install per cluster, with all benchmark workloads in one namespace — the same chart on KinD and OpenShift.</a:t>
             </a:r>
           </a:p>
         </p:txBody>
@@ -27305,7 +27305,7 @@
                 </a:solidFill>
                 <a:latin typeface="Calibri"/>
               </a:rPr>
-              <a:t>• Easy to install on a cluster and run against it: KinD or OpenShift</a:t>
+              <a:t>• One install per cluster, all benchmark workloads in one namespace (team1)</a:t>
             </a:r>
           </a:p>
           <a:p>

</xml_diff>

<commit_message>
Deck: say what the plugin-cost slide's numbers are, and what they don't predict
Slide 37 (What AuthBridge costs):
- The subtitle names the source: every number in the condition table
  comes from the study's gsm8k legs (n=50, two deploys each).
- The "tau2 measured / projected" row (1.66x / 2.01x) is removed. The
  ratio is specific to that pair of runs, not a generic figure.
- A new box states the general lesson the ratio supported: AuthBridge's
  cost on a more complex benchmark cannot be estimated well from gsm8k,
  so measure the benchmark itself (two legs, off and on).

Assisted-By: Claude Opus 5.5 <noreply@anthropic.com>
Signed-off-by: Rong Chang <rong@us.ibm.com>
</commit_message>
<xml_diff>
--- a/docs/AutoBench.pptx
+++ b/docs/AutoBench.pptx
@@ -6190,7 +6190,7 @@
                 </a:solidFill>
                 <a:latin typeface="Arial"/>
               </a:rPr>
-              <a:t>v1.36 · OpenShift and KinD · 2026-10-14</a:t>
+              <a:t>v1.36 · OpenShift and KinD · 2026-10-21</a:t>
             </a:r>
           </a:p>
         </p:txBody>
@@ -38823,7 +38823,7 @@
                 </a:solidFill>
                 <a:latin typeface="Arial"/>
               </a:rPr>
-              <a:t>Non-LLM seconds per task, steady state; the designed 13-leg study, n=50, v1.35</a:t>
+              <a:t>Non-LLM seconds per gsm8k task, steady state; the designed study's gsm8k legs, n=50, two deploys each, v1.35</a:t>
             </a:r>
           </a:p>
         </p:txBody>
@@ -39691,7 +39691,7 @@
         </p:nvGraphicFramePr>
         <p:xfrm>
           <a:off x="411480" y="4069080"/>
-          <a:ext cx="6400800" cy="2103120"/>
+          <a:ext cx="6400800" cy="1682496"/>
         </p:xfrm>
         <a:graphic>
           <a:graphicData uri="http://schemas.openxmlformats.org/drawingml/2006/table">
@@ -40077,100 +40077,6 @@
                   <a:tcPr marL="54864" marR="54864" marT="18288" marB="18288" anchor="ctr">
                     <a:solidFill>
                       <a:srgbClr val="FFFFFF"/>
-                    </a:solidFill>
-                  </a:tcPr>
-                </a:tc>
-              </a:tr>
-              <a:tr h="420624">
-                <a:tc>
-                  <a:txBody>
-                    <a:bodyPr wrap="square"/>
-                    <a:lstStyle/>
-                    <a:p>
-                      <a:pPr algn="l"/>
-                      <a:r>
-                        <a:rPr sz="1200" b="0" i="0">
-                          <a:solidFill>
-                            <a:srgbClr val="1F2A44"/>
-                          </a:solidFill>
-                          <a:latin typeface="Arial"/>
-                        </a:rPr>
-                        <a:t>tau2 measured / projected</a:t>
-                      </a:r>
-                    </a:p>
-                  </a:txBody>
-                  <a:tcPr marL="54864" marR="54864" marT="18288" marB="18288" anchor="ctr">
-                    <a:solidFill>
-                      <a:srgbClr val="F3F5F9"/>
-                    </a:solidFill>
-                  </a:tcPr>
-                </a:tc>
-                <a:tc>
-                  <a:txBody>
-                    <a:bodyPr wrap="square"/>
-                    <a:lstStyle/>
-                    <a:p>
-                      <a:pPr algn="r"/>
-                      <a:r>
-                        <a:rPr sz="1200" b="0" i="0">
-                          <a:solidFill>
-                            <a:srgbClr val="1F2A44"/>
-                          </a:solidFill>
-                          <a:latin typeface="Arial"/>
-                        </a:rPr>
-                        <a:t>1.66×</a:t>
-                      </a:r>
-                    </a:p>
-                  </a:txBody>
-                  <a:tcPr marL="54864" marR="54864" marT="18288" marB="18288" anchor="ctr">
-                    <a:solidFill>
-                      <a:srgbClr val="F3F5F9"/>
-                    </a:solidFill>
-                  </a:tcPr>
-                </a:tc>
-                <a:tc>
-                  <a:txBody>
-                    <a:bodyPr wrap="square"/>
-                    <a:lstStyle/>
-                    <a:p>
-                      <a:pPr algn="r"/>
-                      <a:r>
-                        <a:rPr sz="1200" b="0" i="0">
-                          <a:solidFill>
-                            <a:srgbClr val="1F2A44"/>
-                          </a:solidFill>
-                          <a:latin typeface="Arial"/>
-                        </a:rPr>
-                        <a:t>2.01×</a:t>
-                      </a:r>
-                    </a:p>
-                  </a:txBody>
-                  <a:tcPr marL="54864" marR="54864" marT="18288" marB="18288" anchor="ctr">
-                    <a:solidFill>
-                      <a:srgbClr val="F3F5F9"/>
-                    </a:solidFill>
-                  </a:tcPr>
-                </a:tc>
-                <a:tc>
-                  <a:txBody>
-                    <a:bodyPr wrap="square"/>
-                    <a:lstStyle/>
-                    <a:p>
-                      <a:pPr algn="r"/>
-                      <a:r>
-                        <a:rPr sz="1200" b="0" i="0">
-                          <a:solidFill>
-                            <a:srgbClr val="1F2A44"/>
-                          </a:solidFill>
-                          <a:latin typeface="Arial"/>
-                        </a:rPr>
-                        <a:t>partly</a:t>
-                      </a:r>
-                    </a:p>
-                  </a:txBody>
-                  <a:tcPr marL="54864" marR="54864" marT="18288" marB="18288" anchor="ctr">
-                    <a:solidFill>
-                      <a:srgbClr val="F3F5F9"/>
                     </a:solidFill>
                   </a:tcPr>
                 </a:tc>
@@ -40329,6 +40235,83 @@
                 <a:latin typeface="Arial"/>
               </a:rPr>
               <a:t>The between-deploy noise floor is 0.02 s on OpenShift and 0.12 s on KinD, and ~0.26 s of each judged call on KinD is the node's DNS being retried.</a:t>
+            </a:r>
+          </a:p>
+        </p:txBody>
+      </p:sp>
+      <p:sp>
+        <p:nvSpPr>
+          <p:cNvPr id="12" name="Rounded Rectangle 11"/>
+          <p:cNvSpPr/>
+          <p:nvPr/>
+        </p:nvSpPr>
+        <p:spPr>
+          <a:xfrm>
+            <a:off x="7040880" y="4297680"/>
+            <a:ext cx="4736592" cy="1600200"/>
+          </a:xfrm>
+          <a:prstGeom prst="roundRect">
+            <a:avLst>
+              <a:gd name="adj" fmla="val 9142"/>
+            </a:avLst>
+          </a:prstGeom>
+          <a:solidFill>
+            <a:srgbClr val="FBECEA"/>
+          </a:solidFill>
+          <a:ln w="15875">
+            <a:solidFill>
+              <a:srgbClr val="B03A2E"/>
+            </a:solidFill>
+          </a:ln>
+          <a:effectLst/>
+        </p:spPr>
+        <p:style>
+          <a:lnRef idx="1">
+            <a:schemeClr val="accent1"/>
+          </a:lnRef>
+          <a:fillRef idx="3">
+            <a:schemeClr val="accent1"/>
+          </a:fillRef>
+          <a:effectRef idx="2">
+            <a:schemeClr val="accent1"/>
+          </a:effectRef>
+          <a:fontRef idx="minor">
+            <a:schemeClr val="lt1"/>
+          </a:fontRef>
+        </p:style>
+        <p:txBody>
+          <a:bodyPr rtlCol="0" anchor="t" lIns="73152" rIns="73152" tIns="36576" bIns="36576" wrap="square"/>
+          <a:lstStyle/>
+          <a:p>
+            <a:pPr algn="l">
+              <a:spcAft>
+                <a:spcPts val="200"/>
+              </a:spcAft>
+            </a:pPr>
+            <a:r>
+              <a:rPr sz="1200" b="1" i="0">
+                <a:solidFill>
+                  <a:srgbClr val="1F2A44"/>
+                </a:solidFill>
+                <a:latin typeface="Arial"/>
+              </a:rPr>
+              <a:t>gsm8k does not predict a harder benchmark</a:t>
+            </a:r>
+          </a:p>
+          <a:p>
+            <a:pPr algn="l">
+              <a:spcAft>
+                <a:spcPts val="200"/>
+              </a:spcAft>
+            </a:pPr>
+            <a:r>
+              <a:rPr sz="1200" b="0" i="0">
+                <a:solidFill>
+                  <a:srgbClr val="1F2A44"/>
+                </a:solidFill>
+                <a:latin typeface="Arial"/>
+              </a:rPr>
+              <a:t>AuthBridge's cost on a more complex benchmark cannot be estimated well from gsm8k: on tau2, scaling gsm8k's cost per tool call under-shot the measured cost on both clusters. Measure the benchmark itself: two legs, AuthBridge off and on.</a:t>
             </a:r>
           </a:p>
         </p:txBody>

</xml_diff>